<commit_message>
docs: update presentation files for EDA comparison and complete analysis
</commit_message>
<xml_diff>
--- a/docs/Apresentacoes_IVS/2_EDA_Completa_Corrigida.pptx
+++ b/docs/Apresentacoes_IVS/2_EDA_Completa_Corrigida.pptx
@@ -4,6 +4,9 @@
   <p:sldMasterIdLst>
     <p:sldMasterId id="2147483648" r:id="rId1"/>
   </p:sldMasterIdLst>
+  <p:notesMasterIdLst>
+    <p:notesMasterId r:id="rId13"/>
+  </p:notesMasterIdLst>
   <p:sldIdLst>
     <p:sldId id="256" r:id="rId2"/>
     <p:sldId id="257" r:id="rId3"/>
@@ -17,10 +20,7 @@
     <p:sldId id="265" r:id="rId11"/>
     <p:sldId id="266" r:id="rId12"/>
   </p:sldIdLst>
-  <p:notesMasterIdLst>
-    <p:notesMasterId r:id="rId13"/>
-  </p:notesMasterIdLst>
-  <p:sldSz cx="9144000" cy="5143500"/>
+  <p:sldSz cx="9144000" cy="5143500" type="screen16x9"/>
   <p:notesSz cx="5143500" cy="9144000"/>
   <p:defaultTextStyle>
     <a:lvl1pPr marL="0" algn="l" defTabSz="914400" rtl="0" eaLnBrk="1" latinLnBrk="0" hangingPunct="1">
@@ -114,13 +114,20 @@
       </a:defRPr>
     </a:lvl9pPr>
   </p:defaultTextStyle>
+  <p:extLst>
+    <p:ext uri="{EFAFB233-063F-42B5-8137-9DF3F51BA10A}">
+      <p15:sldGuideLst xmlns:p15="http://schemas.microsoft.com/office/powerpoint/2012/main"/>
+    </p:ext>
+  </p:extLst>
 </p:presentation>
 </file>
 
 <file path=ppt/charts/chart1.xml><?xml version="1.0" encoding="utf-8"?>
-<c:chartSpace xmlns:c="http://schemas.openxmlformats.org/drawingml/2006/chart" xmlns:a="http://schemas.openxmlformats.org/drawingml/2006/main" xmlns:r="http://schemas.openxmlformats.org/officeDocument/2006/relationships">
+<c:chartSpace xmlns:c="http://schemas.openxmlformats.org/drawingml/2006/chart" xmlns:a="http://schemas.openxmlformats.org/drawingml/2006/main" xmlns:r="http://schemas.openxmlformats.org/officeDocument/2006/relationships" xmlns:c16r2="http://schemas.microsoft.com/office/drawing/2015/06/chart">
   <c:date1904 val="0"/>
+  <c:lang val="pt-BR"/>
   <c:roundedCorners val="1"/>
+  <c:style val="2"/>
   <c:chart>
     <c:autoTitleDeleted val="1"/>
     <c:plotArea>
@@ -150,54 +157,28 @@
             <a:effectLst/>
           </c:spPr>
           <c:invertIfNegative val="0"/>
-          <c:dLbls>
-            <c:numFmt formatCode="#,##0" sourceLinked="0"/>
-            <c:txPr>
-              <a:bodyPr/>
-              <a:lstStyle/>
-              <a:p>
-                <a:pPr>
-                  <a:defRPr b="0" i="0" strike="noStrike" sz="1200" u="none">
-                    <a:solidFill>
-                      <a:srgbClr val="000000"/>
-                    </a:solidFill>
-                    <a:latin typeface="Arial"/>
-                  </a:defRPr>
-                </a:pPr>
-              </a:p>
-            </c:txPr>
-            <c:showLegendKey val="0"/>
-            <c:showVal val="0"/>
-            <c:showCatName val="0"/>
-            <c:showSerName val="0"/>
-            <c:showPercent val="0"/>
-            <c:showBubbleSize val="0"/>
-            <c:showLeaderLines val="0"/>
-          </c:dLbls>
           <c:cat>
-            <c:multiLvlStrRef>
+            <c:strRef>
               <c:f>Sheet1!$A$2:$A$6</c:f>
-              <c:multiLvlStrCache>
+              <c:strCache>
                 <c:ptCount val="5"/>
-                <c:lvl>
-                  <c:pt idx="0">
-                    <c:v>Norte</c:v>
-                  </c:pt>
-                  <c:pt idx="1">
-                    <c:v>Nordeste</c:v>
-                  </c:pt>
-                  <c:pt idx="2">
-                    <c:v>Centro-Oeste</c:v>
-                  </c:pt>
-                  <c:pt idx="3">
-                    <c:v>Sudeste</c:v>
-                  </c:pt>
-                  <c:pt idx="4">
-                    <c:v>Sul</c:v>
-                  </c:pt>
-                </c:lvl>
-              </c:multiLvlStrCache>
-            </c:multiLvlStrRef>
+                <c:pt idx="0">
+                  <c:v>Norte</c:v>
+                </c:pt>
+                <c:pt idx="1">
+                  <c:v>Nordeste</c:v>
+                </c:pt>
+                <c:pt idx="2">
+                  <c:v>Centro-Oeste</c:v>
+                </c:pt>
+                <c:pt idx="3">
+                  <c:v>Sudeste</c:v>
+                </c:pt>
+                <c:pt idx="4">
+                  <c:v>Sul</c:v>
+                </c:pt>
+              </c:strCache>
+            </c:strRef>
           </c:cat>
           <c:val>
             <c:numRef>
@@ -206,23 +187,28 @@
                 <c:formatCode>General</c:formatCode>
                 <c:ptCount val="5"/>
                 <c:pt idx="0">
-                  <c:v>0.356</c:v>
+                  <c:v>0.35599999999999998</c:v>
                 </c:pt>
                 <c:pt idx="1">
                   <c:v>0.127</c:v>
                 </c:pt>
                 <c:pt idx="2">
-                  <c:v>0.092</c:v>
+                  <c:v>9.1999999999999998E-2</c:v>
                 </c:pt>
                 <c:pt idx="3">
-                  <c:v>0.045</c:v>
+                  <c:v>4.4999999999999998E-2</c:v>
                 </c:pt>
                 <c:pt idx="4">
-                  <c:v>0.035</c:v>
+                  <c:v>3.5000000000000003E-2</c:v>
                 </c:pt>
               </c:numCache>
             </c:numRef>
           </c:val>
+          <c:extLst>
+            <c:ext xmlns:c16="http://schemas.microsoft.com/office/drawing/2014/chart" uri="{C3380CC4-5D6E-409C-BE32-E72D297353CC}">
+              <c16:uniqueId val="{00000000-7265-480E-9794-04D7F36BA308}"/>
+            </c:ext>
+          </c:extLst>
         </c:ser>
         <c:ser>
           <c:idx val="1"/>
@@ -245,54 +231,28 @@
             <a:effectLst/>
           </c:spPr>
           <c:invertIfNegative val="0"/>
-          <c:dLbls>
-            <c:numFmt formatCode="#,##0" sourceLinked="0"/>
-            <c:txPr>
-              <a:bodyPr/>
-              <a:lstStyle/>
-              <a:p>
-                <a:pPr>
-                  <a:defRPr b="0" i="0" strike="noStrike" sz="1200" u="none">
-                    <a:solidFill>
-                      <a:srgbClr val="000000"/>
-                    </a:solidFill>
-                    <a:latin typeface="Arial"/>
-                  </a:defRPr>
-                </a:pPr>
-              </a:p>
-            </c:txPr>
-            <c:showLegendKey val="0"/>
-            <c:showVal val="0"/>
-            <c:showCatName val="0"/>
-            <c:showSerName val="0"/>
-            <c:showPercent val="0"/>
-            <c:showBubbleSize val="0"/>
-            <c:showLeaderLines val="0"/>
-          </c:dLbls>
           <c:cat>
-            <c:multiLvlStrRef>
+            <c:strRef>
               <c:f>Sheet1!$A$2:$A$6</c:f>
-              <c:multiLvlStrCache>
+              <c:strCache>
                 <c:ptCount val="5"/>
-                <c:lvl>
-                  <c:pt idx="0">
-                    <c:v>Norte</c:v>
-                  </c:pt>
-                  <c:pt idx="1">
-                    <c:v>Nordeste</c:v>
-                  </c:pt>
-                  <c:pt idx="2">
-                    <c:v>Centro-Oeste</c:v>
-                  </c:pt>
-                  <c:pt idx="3">
-                    <c:v>Sudeste</c:v>
-                  </c:pt>
-                  <c:pt idx="4">
-                    <c:v>Sul</c:v>
-                  </c:pt>
-                </c:lvl>
-              </c:multiLvlStrCache>
-            </c:multiLvlStrRef>
+                <c:pt idx="0">
+                  <c:v>Norte</c:v>
+                </c:pt>
+                <c:pt idx="1">
+                  <c:v>Nordeste</c:v>
+                </c:pt>
+                <c:pt idx="2">
+                  <c:v>Centro-Oeste</c:v>
+                </c:pt>
+                <c:pt idx="3">
+                  <c:v>Sudeste</c:v>
+                </c:pt>
+                <c:pt idx="4">
+                  <c:v>Sul</c:v>
+                </c:pt>
+              </c:strCache>
+            </c:strRef>
           </c:cat>
           <c:val>
             <c:numRef>
@@ -301,23 +261,28 @@
                 <c:formatCode>General</c:formatCode>
                 <c:ptCount val="5"/>
                 <c:pt idx="0">
-                  <c:v>0.271</c:v>
+                  <c:v>0.27100000000000002</c:v>
                 </c:pt>
                 <c:pt idx="1">
-                  <c:v>0.176</c:v>
+                  <c:v>0.17599999999999999</c:v>
                 </c:pt>
                 <c:pt idx="2">
-                  <c:v>0.094</c:v>
+                  <c:v>9.4E-2</c:v>
                 </c:pt>
                 <c:pt idx="3">
-                  <c:v>0.054</c:v>
+                  <c:v>5.3999999999999999E-2</c:v>
                 </c:pt>
                 <c:pt idx="4">
-                  <c:v>0.039</c:v>
+                  <c:v>3.9E-2</c:v>
                 </c:pt>
               </c:numCache>
             </c:numRef>
           </c:val>
+          <c:extLst>
+            <c:ext xmlns:c16="http://schemas.microsoft.com/office/drawing/2014/chart" uri="{C3380CC4-5D6E-409C-BE32-E72D297353CC}">
+              <c16:uniqueId val="{00000001-7265-480E-9794-04D7F36BA308}"/>
+            </c:ext>
+          </c:extLst>
         </c:ser>
         <c:ser>
           <c:idx val="2"/>
@@ -340,54 +305,28 @@
             <a:effectLst/>
           </c:spPr>
           <c:invertIfNegative val="0"/>
-          <c:dLbls>
-            <c:numFmt formatCode="#,##0" sourceLinked="0"/>
-            <c:txPr>
-              <a:bodyPr/>
-              <a:lstStyle/>
-              <a:p>
-                <a:pPr>
-                  <a:defRPr b="0" i="0" strike="noStrike" sz="1200" u="none">
-                    <a:solidFill>
-                      <a:srgbClr val="000000"/>
-                    </a:solidFill>
-                    <a:latin typeface="Arial"/>
-                  </a:defRPr>
-                </a:pPr>
-              </a:p>
-            </c:txPr>
-            <c:showLegendKey val="0"/>
-            <c:showVal val="0"/>
-            <c:showCatName val="0"/>
-            <c:showSerName val="0"/>
-            <c:showPercent val="0"/>
-            <c:showBubbleSize val="0"/>
-            <c:showLeaderLines val="0"/>
-          </c:dLbls>
           <c:cat>
-            <c:multiLvlStrRef>
+            <c:strRef>
               <c:f>Sheet1!$A$2:$A$6</c:f>
-              <c:multiLvlStrCache>
+              <c:strCache>
                 <c:ptCount val="5"/>
-                <c:lvl>
-                  <c:pt idx="0">
-                    <c:v>Norte</c:v>
-                  </c:pt>
-                  <c:pt idx="1">
-                    <c:v>Nordeste</c:v>
-                  </c:pt>
-                  <c:pt idx="2">
-                    <c:v>Centro-Oeste</c:v>
-                  </c:pt>
-                  <c:pt idx="3">
-                    <c:v>Sudeste</c:v>
-                  </c:pt>
-                  <c:pt idx="4">
-                    <c:v>Sul</c:v>
-                  </c:pt>
-                </c:lvl>
-              </c:multiLvlStrCache>
-            </c:multiLvlStrRef>
+                <c:pt idx="0">
+                  <c:v>Norte</c:v>
+                </c:pt>
+                <c:pt idx="1">
+                  <c:v>Nordeste</c:v>
+                </c:pt>
+                <c:pt idx="2">
+                  <c:v>Centro-Oeste</c:v>
+                </c:pt>
+                <c:pt idx="3">
+                  <c:v>Sudeste</c:v>
+                </c:pt>
+                <c:pt idx="4">
+                  <c:v>Sul</c:v>
+                </c:pt>
+              </c:strCache>
+            </c:strRef>
           </c:cat>
           <c:val>
             <c:numRef>
@@ -396,10 +335,10 @@
                 <c:formatCode>General</c:formatCode>
                 <c:ptCount val="5"/>
                 <c:pt idx="0">
-                  <c:v>0.14</c:v>
+                  <c:v>0.14000000000000001</c:v>
                 </c:pt>
                 <c:pt idx="1">
-                  <c:v>0.165</c:v>
+                  <c:v>0.16500000000000001</c:v>
                 </c:pt>
                 <c:pt idx="2">
                   <c:v>0.12</c:v>
@@ -413,36 +352,23 @@
               </c:numCache>
             </c:numRef>
           </c:val>
+          <c:extLst>
+            <c:ext xmlns:c16="http://schemas.microsoft.com/office/drawing/2014/chart" uri="{C3380CC4-5D6E-409C-BE32-E72D297353CC}">
+              <c16:uniqueId val="{00000002-7265-480E-9794-04D7F36BA308}"/>
+            </c:ext>
+          </c:extLst>
         </c:ser>
         <c:dLbls>
-          <c:numFmt formatCode="#,##0" sourceLinked="0"/>
-          <c:txPr>
-            <a:bodyPr/>
-            <a:lstStyle/>
-            <a:p>
-              <a:pPr>
-                <a:defRPr b="0" i="0" strike="noStrike" sz="1200" u="none">
-                  <a:solidFill>
-                    <a:srgbClr val="000000"/>
-                  </a:solidFill>
-                  <a:latin typeface="Arial"/>
-                </a:defRPr>
-              </a:pPr>
-            </a:p>
-          </c:txPr>
           <c:showLegendKey val="0"/>
           <c:showVal val="0"/>
           <c:showCatName val="0"/>
           <c:showSerName val="0"/>
           <c:showPercent val="0"/>
           <c:showBubbleSize val="0"/>
-          <c:showLeaderLines val="0"/>
         </c:dLbls>
         <c:gapWidth val="150"/>
-        <c:overlap val="0"/>
         <c:axId val="2094734554"/>
         <c:axId val="2094734552"/>
-        <c:axId val="2094734556"/>
       </c:barChart>
       <c:catAx>
         <c:axId val="2094734554"/>
@@ -483,6 +409,7 @@
         <c:crosses val="autoZero"/>
         <c:auto val="1"/>
         <c:lblAlgn val="ctr"/>
+        <c:lblOffset val="100"/>
         <c:noMultiLvlLbl val="1"/>
       </c:catAx>
       <c:valAx>
@@ -553,7 +480,7 @@
         <a:lstStyle/>
         <a:p>
           <a:pPr>
-            <a:defRPr sz="1100">      </a:defRPr>
+            <a:defRPr sz="1100"/>
           </a:pPr>
           <a:endParaRPr lang="en-US"/>
         </a:p>
@@ -561,6 +488,7 @@
     </c:legend>
     <c:plotVisOnly val="1"/>
     <c:dispBlanksAs val="span"/>
+    <c:showDLblsOverMax val="1"/>
   </c:chart>
   <c:spPr>
     <a:solidFill>
@@ -599,234 +527,10 @@
           <a:chExt cx="0" cy="0"/>
         </a:xfrm>
       </p:grpSpPr>
-      <p:sp>
-        <p:nvSpPr>
-          <p:cNvPr id="2" name="Header Placeholder 1"/>
-          <p:cNvSpPr>
-            <a:spLocks noGrp="1"/>
-          </p:cNvSpPr>
-          <p:nvPr>
-            <p:ph type="hdr" sz="quarter"/>
-          </p:nvPr>
-        </p:nvSpPr>
-        <p:spPr>
-          <a:xfrm>
-            <a:off x="0" y="0"/>
-            <a:ext cx="2971800" cy="458788"/>
-          </a:xfrm>
-          <a:prstGeom prst="rect">
-            <a:avLst/>
-          </a:prstGeom>
-        </p:spPr>
-        <p:txBody>
-          <a:bodyPr vert="horz" lIns="91440" tIns="45720" rIns="91440" bIns="45720" rtlCol="0"/>
-          <a:lstStyle>
-            <a:lvl1pPr algn="l">
-              <a:defRPr sz="1200"/>
-            </a:lvl1pPr>
-          </a:lstStyle>
-          <a:p>
-            <a:endParaRPr lang="en-US"/>
-          </a:p>
-        </p:txBody>
-      </p:sp>
-      <p:sp>
-        <p:nvSpPr>
-          <p:cNvPr id="3" name="Date Placeholder 2"/>
-          <p:cNvSpPr>
-            <a:spLocks noGrp="1"/>
-          </p:cNvSpPr>
-          <p:nvPr>
-            <p:ph type="dt" idx="1"/>
-          </p:nvPr>
-        </p:nvSpPr>
-        <p:spPr>
-          <a:xfrm>
-            <a:off x="3884613" y="0"/>
-            <a:ext cx="2971800" cy="458788"/>
-          </a:xfrm>
-          <a:prstGeom prst="rect">
-            <a:avLst/>
-          </a:prstGeom>
-        </p:spPr>
-        <p:txBody>
-          <a:bodyPr vert="horz" lIns="91440" tIns="45720" rIns="91440" bIns="45720" rtlCol="0"/>
-          <a:lstStyle>
-            <a:lvl1pPr algn="r">
-              <a:defRPr sz="1200"/>
-            </a:lvl1pPr>
-          </a:lstStyle>
-          <a:p>
-            <a:fld id="{5282F153-3F37-0F45-9E97-73ACFA13230C}" type="datetimeFigureOut">
-              <a:rPr lang="en-US"/>
-              <a:t>7/23/19</a:t>
-            </a:fld>
-            <a:endParaRPr lang="en-US"/>
-          </a:p>
-        </p:txBody>
-      </p:sp>
-      <p:sp>
-        <p:nvSpPr>
-          <p:cNvPr id="4" name="Slide Image Placeholder 3"/>
-          <p:cNvSpPr>
-            <a:spLocks noGrp="1" noRot="1" noChangeAspect="1"/>
-          </p:cNvSpPr>
-          <p:nvPr>
-            <p:ph type="sldImg" idx="2"/>
-          </p:nvPr>
-        </p:nvSpPr>
-        <p:spPr>
-          <a:xfrm>
-            <a:off x="685800" y="1143000"/>
-            <a:ext cx="5486400" cy="3086100"/>
-          </a:xfrm>
-          <a:prstGeom prst="rect">
-            <a:avLst/>
-          </a:prstGeom>
-          <a:noFill/>
-          <a:ln w="12700">
-            <a:solidFill>
-              <a:prstClr val="black"/>
-            </a:solidFill>
-          </a:ln>
-        </p:spPr>
-        <p:txBody>
-          <a:bodyPr vert="horz" lIns="91440" tIns="45720" rIns="91440" bIns="45720" rtlCol="0" anchor="ctr"/>
-          <a:lstStyle/>
-          <a:p>
-            <a:endParaRPr lang="en-US"/>
-          </a:p>
-        </p:txBody>
-      </p:sp>
-      <p:sp>
-        <p:nvSpPr>
-          <p:cNvPr id="5" name="Notes Placeholder 4"/>
-          <p:cNvSpPr>
-            <a:spLocks noGrp="1"/>
-          </p:cNvSpPr>
-          <p:nvPr>
-            <p:ph type="body" sz="quarter" idx="3"/>
-          </p:nvPr>
-        </p:nvSpPr>
-        <p:spPr>
-          <a:xfrm>
-            <a:off x="685800" y="4400550"/>
-            <a:ext cx="5486400" cy="3600450"/>
-          </a:xfrm>
-          <a:prstGeom prst="rect">
-            <a:avLst/>
-          </a:prstGeom>
-        </p:spPr>
-        <p:txBody>
-          <a:bodyPr vert="horz" lIns="91440" tIns="45720" rIns="91440" bIns="45720" rtlCol="0"/>
-          <a:lstStyle/>
-          <a:p>
-            <a:pPr lvl="0"/>
-            <a:r>
-              <a:rPr lang="en-US"/>
-              <a:t>Click to edit Master text styles</a:t>
-            </a:r>
-          </a:p>
-          <a:p>
-            <a:pPr lvl="1"/>
-            <a:r>
-              <a:rPr lang="en-US"/>
-              <a:t>Second level</a:t>
-            </a:r>
-          </a:p>
-          <a:p>
-            <a:pPr lvl="2"/>
-            <a:r>
-              <a:rPr lang="en-US"/>
-              <a:t>Third level</a:t>
-            </a:r>
-          </a:p>
-          <a:p>
-            <a:pPr lvl="3"/>
-            <a:r>
-              <a:rPr lang="en-US"/>
-              <a:t>Fourth level</a:t>
-            </a:r>
-          </a:p>
-          <a:p>
-            <a:pPr lvl="4"/>
-            <a:r>
-              <a:rPr lang="en-US"/>
-              <a:t>Fifth level</a:t>
-            </a:r>
-          </a:p>
-        </p:txBody>
-      </p:sp>
-      <p:sp>
-        <p:nvSpPr>
-          <p:cNvPr id="6" name="Footer Placeholder 5"/>
-          <p:cNvSpPr>
-            <a:spLocks noGrp="1"/>
-          </p:cNvSpPr>
-          <p:nvPr>
-            <p:ph type="ftr" sz="quarter" idx="4"/>
-          </p:nvPr>
-        </p:nvSpPr>
-        <p:spPr>
-          <a:xfrm>
-            <a:off x="0" y="8685213"/>
-            <a:ext cx="2971800" cy="458787"/>
-          </a:xfrm>
-          <a:prstGeom prst="rect">
-            <a:avLst/>
-          </a:prstGeom>
-        </p:spPr>
-        <p:txBody>
-          <a:bodyPr vert="horz" lIns="91440" tIns="45720" rIns="91440" bIns="45720" rtlCol="0" anchor="b"/>
-          <a:lstStyle>
-            <a:lvl1pPr algn="l">
-              <a:defRPr sz="1200"/>
-            </a:lvl1pPr>
-          </a:lstStyle>
-          <a:p>
-            <a:endParaRPr lang="en-US"/>
-          </a:p>
-        </p:txBody>
-      </p:sp>
-      <p:sp>
-        <p:nvSpPr>
-          <p:cNvPr id="7" name="Slide Number Placeholder 6"/>
-          <p:cNvSpPr>
-            <a:spLocks noGrp="1"/>
-          </p:cNvSpPr>
-          <p:nvPr>
-            <p:ph type="sldNum" sz="quarter" idx="5"/>
-          </p:nvPr>
-        </p:nvSpPr>
-        <p:spPr>
-          <a:xfrm>
-            <a:off x="3884613" y="8685213"/>
-            <a:ext cx="2971800" cy="458787"/>
-          </a:xfrm>
-          <a:prstGeom prst="rect">
-            <a:avLst/>
-          </a:prstGeom>
-        </p:spPr>
-        <p:txBody>
-          <a:bodyPr vert="horz" lIns="91440" tIns="45720" rIns="91440" bIns="45720" rtlCol="0" anchor="b"/>
-          <a:lstStyle>
-            <a:lvl1pPr algn="r">
-              <a:defRPr sz="1200"/>
-            </a:lvl1pPr>
-          </a:lstStyle>
-          <a:p>
-            <a:fld id="{CE5E9CC1-C706-0F49-92D6-E571CC5EEA8F}" type="slidenum">
-              <a:rPr lang="en-US"/>
-              <a:t>‹#›</a:t>
-            </a:fld>
-            <a:endParaRPr lang="en-US"/>
-          </a:p>
-        </p:txBody>
-      </p:sp>
     </p:spTree>
     <p:extLst>
       <p:ext uri="{BB962C8B-B14F-4D97-AF65-F5344CB8AC3E}">
-        <p14:creationId xmlns:p14="http://schemas.microsoft.com/office/powerpoint/2010/main" val="1024086991"/>
+        <p14:creationId xmlns:p14="http://schemas.microsoft.com/office/powerpoint/2010/main" val="2292335043"/>
       </p:ext>
     </p:extLst>
   </p:cSld>
@@ -970,10 +674,6 @@
           <a:bodyPr/>
           <a:lstStyle/>
           <a:p>
-            <a:r>
-              <a:rPr lang="en-US" dirty="0"/>
-              <a:t/>
-            </a:r>
             <a:endParaRPr lang="en-US" dirty="0"/>
           </a:p>
         </p:txBody>
@@ -1058,10 +758,6 @@
           <a:bodyPr/>
           <a:lstStyle/>
           <a:p>
-            <a:r>
-              <a:rPr lang="en-US" dirty="0"/>
-              <a:t/>
-            </a:r>
             <a:endParaRPr lang="en-US" dirty="0"/>
           </a:p>
         </p:txBody>
@@ -1146,10 +842,6 @@
           <a:bodyPr/>
           <a:lstStyle/>
           <a:p>
-            <a:r>
-              <a:rPr lang="en-US" dirty="0"/>
-              <a:t/>
-            </a:r>
             <a:endParaRPr lang="en-US" dirty="0"/>
           </a:p>
         </p:txBody>
@@ -1234,10 +926,6 @@
           <a:bodyPr/>
           <a:lstStyle/>
           <a:p>
-            <a:r>
-              <a:rPr lang="en-US" dirty="0"/>
-              <a:t/>
-            </a:r>
             <a:endParaRPr lang="en-US" dirty="0"/>
           </a:p>
         </p:txBody>
@@ -1322,10 +1010,6 @@
           <a:bodyPr/>
           <a:lstStyle/>
           <a:p>
-            <a:r>
-              <a:rPr lang="en-US" dirty="0"/>
-              <a:t/>
-            </a:r>
             <a:endParaRPr lang="en-US" dirty="0"/>
           </a:p>
         </p:txBody>
@@ -1410,10 +1094,6 @@
           <a:bodyPr/>
           <a:lstStyle/>
           <a:p>
-            <a:r>
-              <a:rPr lang="en-US" dirty="0"/>
-              <a:t/>
-            </a:r>
             <a:endParaRPr lang="en-US" dirty="0"/>
           </a:p>
         </p:txBody>
@@ -1498,10 +1178,6 @@
           <a:bodyPr/>
           <a:lstStyle/>
           <a:p>
-            <a:r>
-              <a:rPr lang="en-US" dirty="0"/>
-              <a:t/>
-            </a:r>
             <a:endParaRPr lang="en-US" dirty="0"/>
           </a:p>
         </p:txBody>
@@ -1586,10 +1262,6 @@
           <a:bodyPr/>
           <a:lstStyle/>
           <a:p>
-            <a:r>
-              <a:rPr lang="en-US" dirty="0"/>
-              <a:t/>
-            </a:r>
             <a:endParaRPr lang="en-US" dirty="0"/>
           </a:p>
         </p:txBody>
@@ -1674,10 +1346,6 @@
           <a:bodyPr/>
           <a:lstStyle/>
           <a:p>
-            <a:r>
-              <a:rPr lang="en-US" dirty="0"/>
-              <a:t/>
-            </a:r>
             <a:endParaRPr lang="en-US" dirty="0"/>
           </a:p>
         </p:txBody>
@@ -1762,10 +1430,6 @@
           <a:bodyPr/>
           <a:lstStyle/>
           <a:p>
-            <a:r>
-              <a:rPr lang="en-US" dirty="0"/>
-              <a:t/>
-            </a:r>
             <a:endParaRPr lang="en-US" dirty="0"/>
           </a:p>
         </p:txBody>
@@ -1850,10 +1514,6 @@
           <a:bodyPr/>
           <a:lstStyle/>
           <a:p>
-            <a:r>
-              <a:rPr lang="en-US" dirty="0"/>
-              <a:t/>
-            </a:r>
             <a:endParaRPr lang="en-US" dirty="0"/>
           </a:p>
         </p:txBody>
@@ -1927,6 +1587,11 @@
 <file path=ppt/slideMasters/slideMaster1.xml><?xml version="1.0" encoding="utf-8"?>
 <p:sldMaster xmlns:a="http://schemas.openxmlformats.org/drawingml/2006/main" xmlns:r="http://schemas.openxmlformats.org/officeDocument/2006/relationships" xmlns:p="http://schemas.openxmlformats.org/presentationml/2006/main">
   <p:cSld>
+    <p:bg>
+      <p:bgRef idx="1001">
+        <a:schemeClr val="bg1"/>
+      </p:bgRef>
+    </p:bg>
     <p:spTree>
       <p:nvGrpSpPr>
         <p:cNvPr id="1" name=""/>
@@ -2209,6 +1874,7 @@
         <a:solidFill>
           <a:srgbClr val="0B2447"/>
         </a:solidFill>
+        <a:effectLst/>
       </p:bgPr>
     </p:bg>
     <p:spTree>
@@ -2244,6 +1910,13 @@
           </a:solidFill>
           <a:ln/>
         </p:spPr>
+        <p:txBody>
+          <a:bodyPr/>
+          <a:lstStyle/>
+          <a:p>
+            <a:endParaRPr/>
+          </a:p>
+        </p:txBody>
       </p:sp>
       <p:sp>
         <p:nvSpPr>
@@ -2266,11 +1939,11 @@
           <a:bodyPr wrap="square" lIns="0" tIns="0" rIns="0" bIns="0" rtlCol="0" anchor="ctr"/>
           <a:lstStyle/>
           <a:p>
-            <a:pPr indent="0" marL="0">
+            <a:pPr marL="0" indent="0">
               <a:buNone/>
             </a:pPr>
             <a:r>
-              <a:rPr lang="en-US" sz="1300" b="1" spc="200" kern="0" dirty="0">
+              <a:rPr lang="en-US" sz="1300" b="1" kern="0" spc="200" dirty="0">
                 <a:solidFill>
                   <a:srgbClr val="8FB7D9"/>
                 </a:solidFill>
@@ -2305,7 +1978,7 @@
           <a:bodyPr wrap="square" lIns="0" tIns="0" rIns="0" bIns="0" rtlCol="0" anchor="ctr"/>
           <a:lstStyle/>
           <a:p>
-            <a:pPr indent="0" marL="0">
+            <a:pPr marL="0" indent="0">
               <a:lnSpc>
                 <a:spcPct val="102000"/>
               </a:lnSpc>
@@ -2325,7 +1998,7 @@
             <a:endParaRPr lang="en-US" sz="3800" dirty="0"/>
           </a:p>
           <a:p>
-            <a:pPr indent="0" marL="0">
+            <a:pPr marL="0" indent="0">
               <a:lnSpc>
                 <a:spcPct val="102000"/>
               </a:lnSpc>
@@ -2367,7 +2040,7 @@
           <a:bodyPr wrap="square" lIns="0" tIns="0" rIns="0" bIns="0" rtlCol="0" anchor="ctr"/>
           <a:lstStyle/>
           <a:p>
-            <a:pPr indent="0" marL="0">
+            <a:pPr marL="0" indent="0">
               <a:buNone/>
             </a:pPr>
             <a:r>
@@ -2411,6 +2084,13 @@
             <a:prstDash val="solid"/>
           </a:ln>
         </p:spPr>
+        <p:txBody>
+          <a:bodyPr/>
+          <a:lstStyle/>
+          <a:p>
+            <a:endParaRPr/>
+          </a:p>
+        </p:txBody>
       </p:sp>
       <p:sp>
         <p:nvSpPr>
@@ -2433,7 +2113,7 @@
           <a:bodyPr wrap="square" lIns="0" tIns="0" rIns="0" bIns="0" rtlCol="0" anchor="ctr"/>
           <a:lstStyle/>
           <a:p>
-            <a:pPr algn="ctr" indent="0" marL="0">
+            <a:pPr marL="0" indent="0" algn="ctr">
               <a:buNone/>
             </a:pPr>
             <a:r>
@@ -2472,7 +2152,7 @@
           <a:bodyPr wrap="square" lIns="0" tIns="0" rIns="0" bIns="0" rtlCol="0" anchor="ctr"/>
           <a:lstStyle/>
           <a:p>
-            <a:pPr algn="ctr" indent="0" marL="0">
+            <a:pPr marL="0" indent="0" algn="ctr">
               <a:buNone/>
             </a:pPr>
             <a:r>
@@ -2516,6 +2196,13 @@
             <a:prstDash val="solid"/>
           </a:ln>
         </p:spPr>
+        <p:txBody>
+          <a:bodyPr/>
+          <a:lstStyle/>
+          <a:p>
+            <a:endParaRPr/>
+          </a:p>
+        </p:txBody>
       </p:sp>
       <p:sp>
         <p:nvSpPr>
@@ -2538,7 +2225,7 @@
           <a:bodyPr wrap="square" lIns="0" tIns="0" rIns="0" bIns="0" rtlCol="0" anchor="ctr"/>
           <a:lstStyle/>
           <a:p>
-            <a:pPr algn="ctr" indent="0" marL="0">
+            <a:pPr marL="0" indent="0" algn="ctr">
               <a:buNone/>
             </a:pPr>
             <a:r>
@@ -2577,7 +2264,7 @@
           <a:bodyPr wrap="square" lIns="0" tIns="0" rIns="0" bIns="0" rtlCol="0" anchor="ctr"/>
           <a:lstStyle/>
           <a:p>
-            <a:pPr algn="ctr" indent="0" marL="0">
+            <a:pPr marL="0" indent="0" algn="ctr">
               <a:buNone/>
             </a:pPr>
             <a:r>
@@ -2621,6 +2308,13 @@
             <a:prstDash val="solid"/>
           </a:ln>
         </p:spPr>
+        <p:txBody>
+          <a:bodyPr/>
+          <a:lstStyle/>
+          <a:p>
+            <a:endParaRPr/>
+          </a:p>
+        </p:txBody>
       </p:sp>
       <p:sp>
         <p:nvSpPr>
@@ -2643,7 +2337,7 @@
           <a:bodyPr wrap="square" lIns="0" tIns="0" rIns="0" bIns="0" rtlCol="0" anchor="ctr"/>
           <a:lstStyle/>
           <a:p>
-            <a:pPr algn="ctr" indent="0" marL="0">
+            <a:pPr marL="0" indent="0" algn="ctr">
               <a:buNone/>
             </a:pPr>
             <a:r>
@@ -2682,7 +2376,7 @@
           <a:bodyPr wrap="square" lIns="0" tIns="0" rIns="0" bIns="0" rtlCol="0" anchor="ctr"/>
           <a:lstStyle/>
           <a:p>
-            <a:pPr algn="ctr" indent="0" marL="0">
+            <a:pPr marL="0" indent="0" algn="ctr">
               <a:buNone/>
             </a:pPr>
             <a:r>
@@ -2697,45 +2391,6 @@
               <a:t>variáveis / dimensões</a:t>
             </a:r>
             <a:endParaRPr lang="en-US" sz="1100" dirty="0"/>
-          </a:p>
-        </p:txBody>
-      </p:sp>
-      <p:sp>
-        <p:nvSpPr>
-          <p:cNvPr id="15" name="Text 13"/>
-          <p:cNvSpPr/>
-          <p:nvPr/>
-        </p:nvSpPr>
-        <p:spPr>
-          <a:xfrm>
-            <a:off x="822960" y="4636008"/>
-            <a:ext cx="7863840" cy="320040"/>
-          </a:xfrm>
-          <a:prstGeom prst="rect">
-            <a:avLst/>
-          </a:prstGeom>
-          <a:noFill/>
-          <a:ln/>
-        </p:spPr>
-        <p:txBody>
-          <a:bodyPr wrap="square" lIns="0" tIns="0" rIns="0" bIns="0" rtlCol="0" anchor="ctr"/>
-          <a:lstStyle/>
-          <a:p>
-            <a:pPr indent="0" marL="0">
-              <a:buNone/>
-            </a:pPr>
-            <a:r>
-              <a:rPr lang="en-US" sz="1200" dirty="0">
-                <a:solidFill>
-                  <a:srgbClr val="7E97AE"/>
-                </a:solidFill>
-                <a:latin typeface="Calibri" pitchFamily="34" charset="0"/>
-                <a:ea typeface="Calibri" pitchFamily="34" charset="-122"/>
-                <a:cs typeface="Calibri" pitchFamily="34" charset="-120"/>
-              </a:rPr>
-              <a:t>Pedro Dias Soares  ·  Iniciação Científica  ·  Fiocruz Minas — IRR</a:t>
-            </a:r>
-            <a:endParaRPr lang="en-US" sz="1200" dirty="0"/>
           </a:p>
         </p:txBody>
       </p:sp>
@@ -2755,6 +2410,7 @@
         <a:solidFill>
           <a:srgbClr val="FFFFFF"/>
         </a:solidFill>
+        <a:effectLst/>
       </p:bgPr>
     </p:bg>
     <p:spTree>
@@ -2792,11 +2448,11 @@
           <a:bodyPr wrap="square" lIns="0" tIns="0" rIns="0" bIns="0" rtlCol="0" anchor="ctr"/>
           <a:lstStyle/>
           <a:p>
-            <a:pPr indent="0" marL="0">
+            <a:pPr marL="0" indent="0">
               <a:buNone/>
             </a:pPr>
             <a:r>
-              <a:rPr lang="en-US" sz="1100" b="1" spc="200" kern="0" dirty="0">
+              <a:rPr lang="en-US" sz="1100" b="1" kern="0" spc="200" dirty="0">
                 <a:solidFill>
                   <a:srgbClr val="1C7293"/>
                 </a:solidFill>
@@ -2831,7 +2487,7 @@
           <a:bodyPr wrap="square" lIns="0" tIns="0" rIns="0" bIns="0" rtlCol="0" anchor="ctr"/>
           <a:lstStyle/>
           <a:p>
-            <a:pPr indent="0" marL="0">
+            <a:pPr marL="0" indent="0">
               <a:buNone/>
             </a:pPr>
             <a:r>
@@ -2873,13 +2529,20 @@
             <a:prstDash val="solid"/>
           </a:ln>
           <a:effectLst>
-            <a:outerShdw sx="100000" sy="100000" kx="0" ky="0" algn="bl" rotWithShape="0" blurRad="88900" dist="38100" dir="8100000">
+            <a:outerShdw blurRad="88900" dist="38100" dir="8100000" algn="bl" rotWithShape="0">
               <a:srgbClr val="000000">
                 <a:alpha val="15000"/>
               </a:srgbClr>
             </a:outerShdw>
           </a:effectLst>
         </p:spPr>
+        <p:txBody>
+          <a:bodyPr/>
+          <a:lstStyle/>
+          <a:p>
+            <a:endParaRPr/>
+          </a:p>
+        </p:txBody>
       </p:sp>
       <p:sp>
         <p:nvSpPr>
@@ -2900,6 +2563,13 @@
           </a:solidFill>
           <a:ln/>
         </p:spPr>
+        <p:txBody>
+          <a:bodyPr/>
+          <a:lstStyle/>
+          <a:p>
+            <a:endParaRPr/>
+          </a:p>
+        </p:txBody>
       </p:sp>
       <p:sp>
         <p:nvSpPr>
@@ -2922,7 +2592,7 @@
           <a:bodyPr wrap="square" rtlCol="0" anchor="ctr"/>
           <a:lstStyle/>
           <a:p>
-            <a:pPr algn="ctr" indent="0" marL="0">
+            <a:pPr marL="0" indent="0" algn="ctr">
               <a:buNone/>
             </a:pPr>
             <a:r>
@@ -2961,7 +2631,7 @@
           <a:bodyPr wrap="square" lIns="0" tIns="0" rIns="0" bIns="0" rtlCol="0" anchor="ctr"/>
           <a:lstStyle/>
           <a:p>
-            <a:pPr indent="0" marL="0">
+            <a:pPr marL="0" indent="0">
               <a:buNone/>
             </a:pPr>
             <a:r>
@@ -3000,7 +2670,7 @@
           <a:bodyPr wrap="square" lIns="0" tIns="0" rIns="0" bIns="0" rtlCol="0" anchor="ctr"/>
           <a:lstStyle/>
           <a:p>
-            <a:pPr indent="0" marL="0">
+            <a:pPr marL="0" indent="0">
               <a:lnSpc>
                 <a:spcPct val="100000"/>
               </a:lnSpc>
@@ -3045,13 +2715,20 @@
             <a:prstDash val="solid"/>
           </a:ln>
           <a:effectLst>
-            <a:outerShdw sx="100000" sy="100000" kx="0" ky="0" algn="bl" rotWithShape="0" blurRad="88900" dist="38100" dir="8100000">
+            <a:outerShdw blurRad="88900" dist="38100" dir="8100000" algn="bl" rotWithShape="0">
               <a:srgbClr val="000000">
                 <a:alpha val="15000"/>
               </a:srgbClr>
             </a:outerShdw>
           </a:effectLst>
         </p:spPr>
+        <p:txBody>
+          <a:bodyPr/>
+          <a:lstStyle/>
+          <a:p>
+            <a:endParaRPr/>
+          </a:p>
+        </p:txBody>
       </p:sp>
       <p:sp>
         <p:nvSpPr>
@@ -3072,6 +2749,13 @@
           </a:solidFill>
           <a:ln/>
         </p:spPr>
+        <p:txBody>
+          <a:bodyPr/>
+          <a:lstStyle/>
+          <a:p>
+            <a:endParaRPr/>
+          </a:p>
+        </p:txBody>
       </p:sp>
       <p:sp>
         <p:nvSpPr>
@@ -3094,7 +2778,7 @@
           <a:bodyPr wrap="square" rtlCol="0" anchor="ctr"/>
           <a:lstStyle/>
           <a:p>
-            <a:pPr algn="ctr" indent="0" marL="0">
+            <a:pPr marL="0" indent="0" algn="ctr">
               <a:buNone/>
             </a:pPr>
             <a:r>
@@ -3133,7 +2817,7 @@
           <a:bodyPr wrap="square" lIns="0" tIns="0" rIns="0" bIns="0" rtlCol="0" anchor="ctr"/>
           <a:lstStyle/>
           <a:p>
-            <a:pPr indent="0" marL="0">
+            <a:pPr marL="0" indent="0">
               <a:buNone/>
             </a:pPr>
             <a:r>
@@ -3172,7 +2856,7 @@
           <a:bodyPr wrap="square" lIns="0" tIns="0" rIns="0" bIns="0" rtlCol="0" anchor="ctr"/>
           <a:lstStyle/>
           <a:p>
-            <a:pPr indent="0" marL="0">
+            <a:pPr marL="0" indent="0">
               <a:lnSpc>
                 <a:spcPct val="100000"/>
               </a:lnSpc>
@@ -3217,13 +2901,20 @@
             <a:prstDash val="solid"/>
           </a:ln>
           <a:effectLst>
-            <a:outerShdw sx="100000" sy="100000" kx="0" ky="0" algn="bl" rotWithShape="0" blurRad="88900" dist="38100" dir="8100000">
+            <a:outerShdw blurRad="88900" dist="38100" dir="8100000" algn="bl" rotWithShape="0">
               <a:srgbClr val="000000">
                 <a:alpha val="15000"/>
               </a:srgbClr>
             </a:outerShdw>
           </a:effectLst>
         </p:spPr>
+        <p:txBody>
+          <a:bodyPr/>
+          <a:lstStyle/>
+          <a:p>
+            <a:endParaRPr/>
+          </a:p>
+        </p:txBody>
       </p:sp>
       <p:sp>
         <p:nvSpPr>
@@ -3244,6 +2935,13 @@
           </a:solidFill>
           <a:ln/>
         </p:spPr>
+        <p:txBody>
+          <a:bodyPr/>
+          <a:lstStyle/>
+          <a:p>
+            <a:endParaRPr/>
+          </a:p>
+        </p:txBody>
       </p:sp>
       <p:sp>
         <p:nvSpPr>
@@ -3266,7 +2964,7 @@
           <a:bodyPr wrap="square" rtlCol="0" anchor="ctr"/>
           <a:lstStyle/>
           <a:p>
-            <a:pPr algn="ctr" indent="0" marL="0">
+            <a:pPr marL="0" indent="0" algn="ctr">
               <a:buNone/>
             </a:pPr>
             <a:r>
@@ -3305,7 +3003,7 @@
           <a:bodyPr wrap="square" lIns="0" tIns="0" rIns="0" bIns="0" rtlCol="0" anchor="ctr"/>
           <a:lstStyle/>
           <a:p>
-            <a:pPr indent="0" marL="0">
+            <a:pPr marL="0" indent="0">
               <a:buNone/>
             </a:pPr>
             <a:r>
@@ -3344,7 +3042,7 @@
           <a:bodyPr wrap="square" lIns="0" tIns="0" rIns="0" bIns="0" rtlCol="0" anchor="ctr"/>
           <a:lstStyle/>
           <a:p>
-            <a:pPr indent="0" marL="0">
+            <a:pPr marL="0" indent="0">
               <a:lnSpc>
                 <a:spcPct val="100000"/>
               </a:lnSpc>
@@ -3389,13 +3087,20 @@
             <a:prstDash val="solid"/>
           </a:ln>
           <a:effectLst>
-            <a:outerShdw sx="100000" sy="100000" kx="0" ky="0" algn="bl" rotWithShape="0" blurRad="88900" dist="38100" dir="8100000">
+            <a:outerShdw blurRad="88900" dist="38100" dir="8100000" algn="bl" rotWithShape="0">
               <a:srgbClr val="000000">
                 <a:alpha val="15000"/>
               </a:srgbClr>
             </a:outerShdw>
           </a:effectLst>
         </p:spPr>
+        <p:txBody>
+          <a:bodyPr/>
+          <a:lstStyle/>
+          <a:p>
+            <a:endParaRPr/>
+          </a:p>
+        </p:txBody>
       </p:sp>
       <p:sp>
         <p:nvSpPr>
@@ -3416,6 +3121,13 @@
           </a:solidFill>
           <a:ln/>
         </p:spPr>
+        <p:txBody>
+          <a:bodyPr/>
+          <a:lstStyle/>
+          <a:p>
+            <a:endParaRPr/>
+          </a:p>
+        </p:txBody>
       </p:sp>
       <p:sp>
         <p:nvSpPr>
@@ -3438,7 +3150,7 @@
           <a:bodyPr wrap="square" rtlCol="0" anchor="ctr"/>
           <a:lstStyle/>
           <a:p>
-            <a:pPr algn="ctr" indent="0" marL="0">
+            <a:pPr marL="0" indent="0" algn="ctr">
               <a:buNone/>
             </a:pPr>
             <a:r>
@@ -3477,7 +3189,7 @@
           <a:bodyPr wrap="square" lIns="0" tIns="0" rIns="0" bIns="0" rtlCol="0" anchor="ctr"/>
           <a:lstStyle/>
           <a:p>
-            <a:pPr indent="0" marL="0">
+            <a:pPr marL="0" indent="0">
               <a:buNone/>
             </a:pPr>
             <a:r>
@@ -3516,7 +3228,7 @@
           <a:bodyPr wrap="square" lIns="0" tIns="0" rIns="0" bIns="0" rtlCol="0" anchor="ctr"/>
           <a:lstStyle/>
           <a:p>
-            <a:pPr indent="0" marL="0">
+            <a:pPr marL="0" indent="0">
               <a:lnSpc>
                 <a:spcPct val="100000"/>
               </a:lnSpc>
@@ -3537,81 +3249,6 @@
           </a:p>
         </p:txBody>
       </p:sp>
-      <p:sp>
-        <p:nvSpPr>
-          <p:cNvPr id="24" name="Shape 22"/>
-          <p:cNvSpPr/>
-          <p:nvPr/>
-        </p:nvSpPr>
-        <p:spPr>
-          <a:xfrm>
-            <a:off x="457200" y="4434840"/>
-            <a:ext cx="8229600" cy="502920"/>
-          </a:xfrm>
-          <a:prstGeom prst="roundRect">
-            <a:avLst>
-              <a:gd name="adj" fmla="val 10909"/>
-            </a:avLst>
-          </a:prstGeom>
-          <a:solidFill>
-            <a:srgbClr val="0B2447"/>
-          </a:solidFill>
-          <a:ln/>
-        </p:spPr>
-      </p:sp>
-      <p:sp>
-        <p:nvSpPr>
-          <p:cNvPr id="25" name="Text 23"/>
-          <p:cNvSpPr/>
-          <p:nvPr/>
-        </p:nvSpPr>
-        <p:spPr>
-          <a:xfrm>
-            <a:off x="457200" y="4434840"/>
-            <a:ext cx="8229600" cy="502920"/>
-          </a:xfrm>
-          <a:prstGeom prst="rect">
-            <a:avLst/>
-          </a:prstGeom>
-          <a:noFill/>
-          <a:ln/>
-        </p:spPr>
-        <p:txBody>
-          <a:bodyPr wrap="square" lIns="0" tIns="0" rIns="0" bIns="0" rtlCol="0" anchor="ctr"/>
-          <a:lstStyle/>
-          <a:p>
-            <a:pPr algn="ctr" indent="0" marL="0">
-              <a:buNone/>
-            </a:pPr>
-            <a:r>
-              <a:rPr lang="en-US" sz="1250" b="1" dirty="0">
-                <a:solidFill>
-                  <a:srgbClr val="2A9D8F"/>
-                </a:solidFill>
-                <a:latin typeface="Calibri" pitchFamily="34" charset="0"/>
-                <a:ea typeface="Calibri" pitchFamily="34" charset="-122"/>
-                <a:cs typeface="Calibri" pitchFamily="34" charset="-120"/>
-              </a:rPr>
-              <a:t>Regra geral:  </a:t>
-            </a:r>
-            <a:pPr algn="ctr" indent="0" marL="0">
-              <a:buNone/>
-            </a:pPr>
-            <a:r>
-              <a:rPr lang="en-US" sz="1250" dirty="0">
-                <a:solidFill>
-                  <a:srgbClr val="FFFFFF"/>
-                </a:solidFill>
-                <a:latin typeface="Calibri" pitchFamily="34" charset="0"/>
-                <a:ea typeface="Calibri" pitchFamily="34" charset="-122"/>
-                <a:cs typeface="Calibri" pitchFamily="34" charset="-120"/>
-              </a:rPr>
-              <a:t>dada a assimetria, usar mediana/IQR nas descritivas e Spearman nas correlações ao longo de todo o artigo.</a:t>
-            </a:r>
-            <a:endParaRPr lang="en-US" sz="1250" dirty="0"/>
-          </a:p>
-        </p:txBody>
-      </p:sp>
     </p:spTree>
   </p:cSld>
   <p:clrMapOvr>
@@ -3628,6 +3265,7 @@
         <a:solidFill>
           <a:srgbClr val="0B2447"/>
         </a:solidFill>
+        <a:effectLst/>
       </p:bgPr>
     </p:bg>
     <p:spTree>
@@ -3663,6 +3301,13 @@
           </a:solidFill>
           <a:ln/>
         </p:spPr>
+        <p:txBody>
+          <a:bodyPr/>
+          <a:lstStyle/>
+          <a:p>
+            <a:endParaRPr/>
+          </a:p>
+        </p:txBody>
       </p:sp>
       <p:sp>
         <p:nvSpPr>
@@ -3685,11 +3330,11 @@
           <a:bodyPr wrap="square" lIns="0" tIns="0" rIns="0" bIns="0" rtlCol="0" anchor="ctr"/>
           <a:lstStyle/>
           <a:p>
-            <a:pPr indent="0" marL="0">
+            <a:pPr marL="0" indent="0">
               <a:buNone/>
             </a:pPr>
             <a:r>
-              <a:rPr lang="en-US" sz="1200" b="1" spc="200" kern="0" dirty="0">
+              <a:rPr lang="en-US" sz="1200" b="1" kern="0" spc="200" dirty="0">
                 <a:solidFill>
                   <a:srgbClr val="8FB7D9"/>
                 </a:solidFill>
@@ -3705,52 +3350,13 @@
       </p:sp>
       <p:sp>
         <p:nvSpPr>
-          <p:cNvPr id="4" name="Text 2"/>
-          <p:cNvSpPr/>
-          <p:nvPr/>
-        </p:nvSpPr>
-        <p:spPr>
-          <a:xfrm>
-            <a:off x="822960" y="822960"/>
-            <a:ext cx="7772400" cy="548640"/>
-          </a:xfrm>
-          <a:prstGeom prst="rect">
-            <a:avLst/>
-          </a:prstGeom>
-          <a:noFill/>
-          <a:ln/>
-        </p:spPr>
-        <p:txBody>
-          <a:bodyPr wrap="square" lIns="0" tIns="0" rIns="0" bIns="0" rtlCol="0" anchor="ctr"/>
-          <a:lstStyle/>
-          <a:p>
-            <a:pPr indent="0" marL="0">
-              <a:buNone/>
-            </a:pPr>
-            <a:r>
-              <a:rPr lang="en-US" sz="2800" b="1" dirty="0">
-                <a:solidFill>
-                  <a:srgbClr val="FFFFFF"/>
-                </a:solidFill>
-                <a:latin typeface="Georgia" pitchFamily="34" charset="0"/>
-                <a:ea typeface="Georgia" pitchFamily="34" charset="-122"/>
-                <a:cs typeface="Georgia" pitchFamily="34" charset="-120"/>
-              </a:rPr>
-              <a:t>A EDA sustenta o desenho do IVS</a:t>
-            </a:r>
-            <a:endParaRPr lang="en-US" sz="2800" dirty="0"/>
-          </a:p>
-        </p:txBody>
-      </p:sp>
-      <p:sp>
-        <p:nvSpPr>
           <p:cNvPr id="5" name="Text 3"/>
           <p:cNvSpPr/>
           <p:nvPr/>
         </p:nvSpPr>
         <p:spPr>
           <a:xfrm>
-            <a:off x="960120" y="1554480"/>
+            <a:off x="777240" y="756920"/>
             <a:ext cx="7589520" cy="1554480"/>
           </a:xfrm>
           <a:prstGeom prst="rect">
@@ -3824,153 +3430,6 @@
           </a:p>
         </p:txBody>
       </p:sp>
-      <p:sp>
-        <p:nvSpPr>
-          <p:cNvPr id="6" name="Shape 4"/>
-          <p:cNvSpPr/>
-          <p:nvPr/>
-        </p:nvSpPr>
-        <p:spPr>
-          <a:xfrm>
-            <a:off x="822960" y="3246120"/>
-            <a:ext cx="7772400" cy="914400"/>
-          </a:xfrm>
-          <a:prstGeom prst="roundRect">
-            <a:avLst>
-              <a:gd name="adj" fmla="val 8000"/>
-            </a:avLst>
-          </a:prstGeom>
-          <a:solidFill>
-            <a:srgbClr val="12365E"/>
-          </a:solidFill>
-          <a:ln w="15875">
-            <a:solidFill>
-              <a:srgbClr val="2A9D8F"/>
-            </a:solidFill>
-            <a:prstDash val="solid"/>
-          </a:ln>
-        </p:spPr>
-      </p:sp>
-      <p:sp>
-        <p:nvSpPr>
-          <p:cNvPr id="7" name="Text 5"/>
-          <p:cNvSpPr/>
-          <p:nvPr/>
-        </p:nvSpPr>
-        <p:spPr>
-          <a:xfrm>
-            <a:off x="1051560" y="3346704"/>
-            <a:ext cx="7315200" cy="274320"/>
-          </a:xfrm>
-          <a:prstGeom prst="rect">
-            <a:avLst/>
-          </a:prstGeom>
-          <a:noFill/>
-          <a:ln/>
-        </p:spPr>
-        <p:txBody>
-          <a:bodyPr wrap="square" lIns="0" tIns="0" rIns="0" bIns="0" rtlCol="0" anchor="ctr"/>
-          <a:lstStyle/>
-          <a:p>
-            <a:pPr indent="0" marL="0">
-              <a:buNone/>
-            </a:pPr>
-            <a:r>
-              <a:rPr lang="en-US" sz="1100" b="1" spc="100" kern="0" dirty="0">
-                <a:solidFill>
-                  <a:srgbClr val="2A9D8F"/>
-                </a:solidFill>
-                <a:latin typeface="Calibri" pitchFamily="34" charset="0"/>
-                <a:ea typeface="Calibri" pitchFamily="34" charset="-122"/>
-                <a:cs typeface="Calibri" pitchFamily="34" charset="-120"/>
-              </a:rPr>
-              <a:t>PRÓXIMOS PASSOS</a:t>
-            </a:r>
-            <a:endParaRPr lang="en-US" sz="1100" dirty="0"/>
-          </a:p>
-        </p:txBody>
-      </p:sp>
-      <p:sp>
-        <p:nvSpPr>
-          <p:cNvPr id="8" name="Text 6"/>
-          <p:cNvSpPr/>
-          <p:nvPr/>
-        </p:nvSpPr>
-        <p:spPr>
-          <a:xfrm>
-            <a:off x="1051560" y="3611880"/>
-            <a:ext cx="7315200" cy="502920"/>
-          </a:xfrm>
-          <a:prstGeom prst="rect">
-            <a:avLst/>
-          </a:prstGeom>
-          <a:noFill/>
-          <a:ln/>
-        </p:spPr>
-        <p:txBody>
-          <a:bodyPr wrap="square" lIns="0" tIns="0" rIns="0" bIns="0" rtlCol="0" anchor="ctr"/>
-          <a:lstStyle/>
-          <a:p>
-            <a:pPr indent="0" marL="0">
-              <a:lnSpc>
-                <a:spcPct val="102000"/>
-              </a:lnSpc>
-              <a:buNone/>
-            </a:pPr>
-            <a:r>
-              <a:rPr lang="en-US" sz="1400" dirty="0">
-                <a:solidFill>
-                  <a:srgbClr val="FFFFFF"/>
-                </a:solidFill>
-                <a:latin typeface="Calibri" pitchFamily="34" charset="0"/>
-                <a:ea typeface="Calibri" pitchFamily="34" charset="-122"/>
-                <a:cs typeface="Calibri" pitchFamily="34" charset="-120"/>
-              </a:rPr>
-              <a:t>normalização por município  →  KMO / Bartlett  →  análise fatorial e pesos  →  IVS final  →  4 faixas de risco  →  mapas (QGIS)</a:t>
-            </a:r>
-            <a:endParaRPr lang="en-US" sz="1400" dirty="0"/>
-          </a:p>
-        </p:txBody>
-      </p:sp>
-      <p:sp>
-        <p:nvSpPr>
-          <p:cNvPr id="9" name="Text 7"/>
-          <p:cNvSpPr/>
-          <p:nvPr/>
-        </p:nvSpPr>
-        <p:spPr>
-          <a:xfrm>
-            <a:off x="822960" y="4343400"/>
-            <a:ext cx="7772400" cy="365760"/>
-          </a:xfrm>
-          <a:prstGeom prst="rect">
-            <a:avLst/>
-          </a:prstGeom>
-          <a:noFill/>
-          <a:ln/>
-        </p:spPr>
-        <p:txBody>
-          <a:bodyPr wrap="square" lIns="0" tIns="0" rIns="0" bIns="0" rtlCol="0" anchor="ctr"/>
-          <a:lstStyle/>
-          <a:p>
-            <a:pPr indent="0" marL="0">
-              <a:buNone/>
-            </a:pPr>
-            <a:r>
-              <a:rPr lang="en-US" sz="1100" i="1" dirty="0">
-                <a:solidFill>
-                  <a:srgbClr val="7E97AE"/>
-                </a:solidFill>
-                <a:latin typeface="Calibri" pitchFamily="34" charset="0"/>
-                <a:ea typeface="Calibri" pitchFamily="34" charset="-122"/>
-                <a:cs typeface="Calibri" pitchFamily="34" charset="-120"/>
-              </a:rPr>
-              <a:t>Fonte: Censo Demográfico 2022 (IBGE) — Agregados por Setores Censitários.  106.281 setores OK, 70 municípios ELSI-Brasil.</a:t>
-            </a:r>
-            <a:endParaRPr lang="en-US" sz="1100" dirty="0"/>
-          </a:p>
-        </p:txBody>
-      </p:sp>
     </p:spTree>
   </p:cSld>
   <p:clrMapOvr>
@@ -3987,6 +3446,7 @@
         <a:solidFill>
           <a:srgbClr val="FFFFFF"/>
         </a:solidFill>
+        <a:effectLst/>
       </p:bgPr>
     </p:bg>
     <p:spTree>
@@ -4024,11 +3484,11 @@
           <a:bodyPr wrap="square" lIns="0" tIns="0" rIns="0" bIns="0" rtlCol="0" anchor="ctr"/>
           <a:lstStyle/>
           <a:p>
-            <a:pPr indent="0" marL="0">
+            <a:pPr marL="0" indent="0">
               <a:buNone/>
             </a:pPr>
             <a:r>
-              <a:rPr lang="en-US" sz="1100" b="1" spc="200" kern="0" dirty="0">
+              <a:rPr lang="en-US" sz="1100" b="1" kern="0" spc="200" dirty="0">
                 <a:solidFill>
                   <a:srgbClr val="1C7293"/>
                 </a:solidFill>
@@ -4039,45 +3499,6 @@
               <a:t>DESENHO DO ESTUDO</a:t>
             </a:r>
             <a:endParaRPr lang="en-US" sz="1100" dirty="0"/>
-          </a:p>
-        </p:txBody>
-      </p:sp>
-      <p:sp>
-        <p:nvSpPr>
-          <p:cNvPr id="3" name="Text 1"/>
-          <p:cNvSpPr/>
-          <p:nvPr/>
-        </p:nvSpPr>
-        <p:spPr>
-          <a:xfrm>
-            <a:off x="457200" y="566928"/>
-            <a:ext cx="8229600" cy="530352"/>
-          </a:xfrm>
-          <a:prstGeom prst="rect">
-            <a:avLst/>
-          </a:prstGeom>
-          <a:noFill/>
-          <a:ln/>
-        </p:spPr>
-        <p:txBody>
-          <a:bodyPr wrap="square" lIns="0" tIns="0" rIns="0" bIns="0" rtlCol="0" anchor="ctr"/>
-          <a:lstStyle/>
-          <a:p>
-            <a:pPr indent="0" marL="0">
-              <a:buNone/>
-            </a:pPr>
-            <a:r>
-              <a:rPr lang="en-US" sz="2600" b="1" dirty="0">
-                <a:solidFill>
-                  <a:srgbClr val="1E2A36"/>
-                </a:solidFill>
-                <a:latin typeface="Georgia" pitchFamily="34" charset="0"/>
-                <a:ea typeface="Georgia" pitchFamily="34" charset="-122"/>
-                <a:cs typeface="Georgia" pitchFamily="34" charset="-120"/>
-              </a:rPr>
-              <a:t>Universo e elegibilidade dos setores</a:t>
-            </a:r>
-            <a:endParaRPr lang="en-US" sz="2600" dirty="0"/>
           </a:p>
         </p:txBody>
       </p:sp>
@@ -4105,13 +3526,20 @@
             <a:prstDash val="solid"/>
           </a:ln>
           <a:effectLst>
-            <a:outerShdw sx="100000" sy="100000" kx="0" ky="0" algn="bl" rotWithShape="0" blurRad="88900" dist="38100" dir="8100000">
+            <a:outerShdw blurRad="88900" dist="38100" dir="8100000" algn="bl" rotWithShape="0">
               <a:srgbClr val="000000">
                 <a:alpha val="15000"/>
               </a:srgbClr>
             </a:outerShdw>
           </a:effectLst>
         </p:spPr>
+        <p:txBody>
+          <a:bodyPr/>
+          <a:lstStyle/>
+          <a:p>
+            <a:endParaRPr/>
+          </a:p>
+        </p:txBody>
       </p:sp>
       <p:sp>
         <p:nvSpPr>
@@ -4132,6 +3560,13 @@
           </a:solidFill>
           <a:ln/>
         </p:spPr>
+        <p:txBody>
+          <a:bodyPr/>
+          <a:lstStyle/>
+          <a:p>
+            <a:endParaRPr/>
+          </a:p>
+        </p:txBody>
       </p:sp>
       <p:sp>
         <p:nvSpPr>
@@ -4154,7 +3589,7 @@
           <a:bodyPr wrap="square" lIns="0" tIns="0" rIns="0" bIns="0" rtlCol="0" anchor="ctr"/>
           <a:lstStyle/>
           <a:p>
-            <a:pPr indent="0" marL="0">
+            <a:pPr marL="0" indent="0">
               <a:buNone/>
             </a:pPr>
             <a:r>
@@ -4193,7 +3628,7 @@
           <a:bodyPr wrap="square" lIns="0" tIns="0" rIns="0" bIns="0" rtlCol="0" anchor="ctr"/>
           <a:lstStyle/>
           <a:p>
-            <a:pPr indent="0" marL="0">
+            <a:pPr marL="0" indent="0">
               <a:lnSpc>
                 <a:spcPct val="95000"/>
               </a:lnSpc>
@@ -4238,13 +3673,20 @@
             <a:prstDash val="solid"/>
           </a:ln>
           <a:effectLst>
-            <a:outerShdw sx="100000" sy="100000" kx="0" ky="0" algn="bl" rotWithShape="0" blurRad="88900" dist="38100" dir="8100000">
+            <a:outerShdw blurRad="88900" dist="38100" dir="8100000" algn="bl" rotWithShape="0">
               <a:srgbClr val="000000">
                 <a:alpha val="15000"/>
               </a:srgbClr>
             </a:outerShdw>
           </a:effectLst>
         </p:spPr>
+        <p:txBody>
+          <a:bodyPr/>
+          <a:lstStyle/>
+          <a:p>
+            <a:endParaRPr/>
+          </a:p>
+        </p:txBody>
       </p:sp>
       <p:sp>
         <p:nvSpPr>
@@ -4265,6 +3707,13 @@
           </a:solidFill>
           <a:ln/>
         </p:spPr>
+        <p:txBody>
+          <a:bodyPr/>
+          <a:lstStyle/>
+          <a:p>
+            <a:endParaRPr/>
+          </a:p>
+        </p:txBody>
       </p:sp>
       <p:sp>
         <p:nvSpPr>
@@ -4287,7 +3736,7 @@
           <a:bodyPr wrap="square" lIns="0" tIns="0" rIns="0" bIns="0" rtlCol="0" anchor="ctr"/>
           <a:lstStyle/>
           <a:p>
-            <a:pPr indent="0" marL="0">
+            <a:pPr marL="0" indent="0">
               <a:buNone/>
             </a:pPr>
             <a:r>
@@ -4326,7 +3775,7 @@
           <a:bodyPr wrap="square" lIns="0" tIns="0" rIns="0" bIns="0" rtlCol="0" anchor="ctr"/>
           <a:lstStyle/>
           <a:p>
-            <a:pPr indent="0" marL="0">
+            <a:pPr marL="0" indent="0">
               <a:lnSpc>
                 <a:spcPct val="95000"/>
               </a:lnSpc>
@@ -4371,13 +3820,20 @@
             <a:prstDash val="solid"/>
           </a:ln>
           <a:effectLst>
-            <a:outerShdw sx="100000" sy="100000" kx="0" ky="0" algn="bl" rotWithShape="0" blurRad="88900" dist="38100" dir="8100000">
+            <a:outerShdw blurRad="88900" dist="38100" dir="8100000" algn="bl" rotWithShape="0">
               <a:srgbClr val="000000">
                 <a:alpha val="15000"/>
               </a:srgbClr>
             </a:outerShdw>
           </a:effectLst>
         </p:spPr>
+        <p:txBody>
+          <a:bodyPr/>
+          <a:lstStyle/>
+          <a:p>
+            <a:endParaRPr/>
+          </a:p>
+        </p:txBody>
       </p:sp>
       <p:sp>
         <p:nvSpPr>
@@ -4398,6 +3854,13 @@
           </a:solidFill>
           <a:ln/>
         </p:spPr>
+        <p:txBody>
+          <a:bodyPr/>
+          <a:lstStyle/>
+          <a:p>
+            <a:endParaRPr/>
+          </a:p>
+        </p:txBody>
       </p:sp>
       <p:sp>
         <p:nvSpPr>
@@ -4420,7 +3883,7 @@
           <a:bodyPr wrap="square" lIns="0" tIns="0" rIns="0" bIns="0" rtlCol="0" anchor="ctr"/>
           <a:lstStyle/>
           <a:p>
-            <a:pPr indent="0" marL="0">
+            <a:pPr marL="0" indent="0">
               <a:buNone/>
             </a:pPr>
             <a:r>
@@ -4459,7 +3922,7 @@
           <a:bodyPr wrap="square" lIns="0" tIns="0" rIns="0" bIns="0" rtlCol="0" anchor="ctr"/>
           <a:lstStyle/>
           <a:p>
-            <a:pPr indent="0" marL="0">
+            <a:pPr marL="0" indent="0">
               <a:lnSpc>
                 <a:spcPct val="95000"/>
               </a:lnSpc>
@@ -4504,6 +3967,13 @@
             <a:prstDash val="solid"/>
           </a:ln>
         </p:spPr>
+        <p:txBody>
+          <a:bodyPr/>
+          <a:lstStyle/>
+          <a:p>
+            <a:endParaRPr/>
+          </a:p>
+        </p:txBody>
       </p:sp>
       <p:sp>
         <p:nvSpPr>
@@ -4526,7 +3996,7 @@
           <a:bodyPr wrap="square" lIns="0" tIns="0" rIns="0" bIns="0" rtlCol="0" anchor="ctr"/>
           <a:lstStyle/>
           <a:p>
-            <a:pPr indent="0" marL="0">
+            <a:pPr marL="0" indent="0">
               <a:buNone/>
             </a:pPr>
             <a:r>
@@ -4565,7 +4035,7 @@
           <a:bodyPr wrap="square" lIns="0" tIns="0" rIns="0" bIns="0" rtlCol="0" anchor="ctr"/>
           <a:lstStyle/>
           <a:p>
-            <a:pPr indent="0" marL="0">
+            <a:pPr marL="0" indent="0">
               <a:lnSpc>
                 <a:spcPct val="115000"/>
               </a:lnSpc>
@@ -4582,12 +4052,6 @@
               </a:rPr>
               <a:t>OK </a:t>
             </a:r>
-            <a:pPr indent="0" marL="0">
-              <a:lnSpc>
-                <a:spcPct val="115000"/>
-              </a:lnSpc>
-              <a:buNone/>
-            </a:pPr>
             <a:r>
               <a:rPr lang="en-US" sz="1300" dirty="0">
                 <a:solidFill>
@@ -4599,12 +4063,6 @@
               </a:rPr>
               <a:t>— v0001 e V00001 presentes; entra nas análises.   </a:t>
             </a:r>
-            <a:pPr indent="0" marL="0">
-              <a:lnSpc>
-                <a:spcPct val="115000"/>
-              </a:lnSpc>
-              <a:buNone/>
-            </a:pPr>
             <a:r>
               <a:rPr lang="en-US" sz="1300" b="1" dirty="0">
                 <a:solidFill>
@@ -4616,12 +4074,6 @@
               </a:rPr>
               <a:t>SIGILOSO </a:t>
             </a:r>
-            <a:pPr indent="0" marL="0">
-              <a:lnSpc>
-                <a:spcPct val="115000"/>
-              </a:lnSpc>
-              <a:buNone/>
-            </a:pPr>
             <a:r>
               <a:rPr lang="en-US" sz="1300" dirty="0">
                 <a:solidFill>
@@ -4636,7 +4088,7 @@
             <a:endParaRPr lang="en-US" sz="1300" dirty="0"/>
           </a:p>
           <a:p>
-            <a:pPr indent="0" marL="0">
+            <a:pPr marL="0" indent="0">
               <a:lnSpc>
                 <a:spcPct val="115000"/>
               </a:lnSpc>
@@ -4653,12 +4105,6 @@
               </a:rPr>
               <a:t>COLETIVO </a:t>
             </a:r>
-            <a:pPr indent="0" marL="0">
-              <a:lnSpc>
-                <a:spcPct val="115000"/>
-              </a:lnSpc>
-              <a:buNone/>
-            </a:pPr>
             <a:r>
               <a:rPr lang="en-US" sz="1300" dirty="0">
                 <a:solidFill>
@@ -4670,12 +4116,6 @@
               </a:rPr>
               <a:t>— V00001=0 com população (asilo/presídio).   </a:t>
             </a:r>
-            <a:pPr indent="0" marL="0">
-              <a:lnSpc>
-                <a:spcPct val="115000"/>
-              </a:lnSpc>
-              <a:buNone/>
-            </a:pPr>
             <a:r>
               <a:rPr lang="en-US" sz="1300" b="1" dirty="0">
                 <a:solidFill>
@@ -4687,12 +4127,6 @@
               </a:rPr>
               <a:t>ZERADO </a:t>
             </a:r>
-            <a:pPr indent="0" marL="0">
-              <a:lnSpc>
-                <a:spcPct val="115000"/>
-              </a:lnSpc>
-              <a:buNone/>
-            </a:pPr>
             <a:r>
               <a:rPr lang="en-US" sz="1300" dirty="0">
                 <a:solidFill>
@@ -4707,7 +4141,7 @@
             <a:endParaRPr lang="en-US" sz="1300" dirty="0"/>
           </a:p>
           <a:p>
-            <a:pPr indent="0" marL="0">
+            <a:pPr marL="0" indent="0">
               <a:lnSpc>
                 <a:spcPct val="115000"/>
               </a:lnSpc>
@@ -4744,6 +4178,7 @@
         <a:solidFill>
           <a:srgbClr val="FFFFFF"/>
         </a:solidFill>
+        <a:effectLst/>
       </p:bgPr>
     </p:bg>
     <p:spTree>
@@ -4781,11 +4216,11 @@
           <a:bodyPr wrap="square" lIns="0" tIns="0" rIns="0" bIns="0" rtlCol="0" anchor="ctr"/>
           <a:lstStyle/>
           <a:p>
-            <a:pPr indent="0" marL="0">
+            <a:pPr marL="0" indent="0">
               <a:buNone/>
             </a:pPr>
             <a:r>
-              <a:rPr lang="en-US" sz="1100" b="1" spc="200" kern="0" dirty="0">
+              <a:rPr lang="en-US" sz="1100" b="1" kern="0" spc="200" dirty="0">
                 <a:solidFill>
                   <a:srgbClr val="1C7293"/>
                 </a:solidFill>
@@ -4820,7 +4255,7 @@
           <a:bodyPr wrap="square" lIns="0" tIns="0" rIns="0" bIns="0" rtlCol="0" anchor="ctr"/>
           <a:lstStyle/>
           <a:p>
-            <a:pPr indent="0" marL="0">
+            <a:pPr marL="0" indent="0">
               <a:buNone/>
             </a:pPr>
             <a:r>
@@ -4854,17 +4289,41 @@
         </p:nvGraphicFramePr>
         <p:xfrm>
           <a:off x="457200" y="1234440"/>
-          <a:ext cx="8229600" cy="914400"/>
+          <a:ext cx="8229600" cy="3017520"/>
         </p:xfrm>
         <a:graphic>
           <a:graphicData uri="http://schemas.openxmlformats.org/drawingml/2006/table">
             <a:tbl>
               <a:tblPr/>
               <a:tblGrid>
-                <a:gridCol w="1371600"/>
-                <a:gridCol w="2468880"/>
-                <a:gridCol w="2651760"/>
-                <a:gridCol w="1737360"/>
+                <a:gridCol w="1371600">
+                  <a:extLst>
+                    <a:ext uri="{9D8B030D-6E8A-4147-A177-3AD203B41FA5}">
+                      <a16:colId xmlns:a16="http://schemas.microsoft.com/office/drawing/2014/main" val="20000"/>
+                    </a:ext>
+                  </a:extLst>
+                </a:gridCol>
+                <a:gridCol w="2468880">
+                  <a:extLst>
+                    <a:ext uri="{9D8B030D-6E8A-4147-A177-3AD203B41FA5}">
+                      <a16:colId xmlns:a16="http://schemas.microsoft.com/office/drawing/2014/main" val="20001"/>
+                    </a:ext>
+                  </a:extLst>
+                </a:gridCol>
+                <a:gridCol w="2651760">
+                  <a:extLst>
+                    <a:ext uri="{9D8B030D-6E8A-4147-A177-3AD203B41FA5}">
+                      <a16:colId xmlns:a16="http://schemas.microsoft.com/office/drawing/2014/main" val="20002"/>
+                    </a:ext>
+                  </a:extLst>
+                </a:gridCol>
+                <a:gridCol w="1737360">
+                  <a:extLst>
+                    <a:ext uri="{9D8B030D-6E8A-4147-A177-3AD203B41FA5}">
+                      <a16:colId xmlns:a16="http://schemas.microsoft.com/office/drawing/2014/main" val="20003"/>
+                    </a:ext>
+                  </a:extLst>
+                </a:gridCol>
               </a:tblGrid>
               <a:tr h="365760">
                 <a:tc>
@@ -4872,7 +4331,7 @@
                     <a:bodyPr/>
                     <a:lstStyle/>
                     <a:p>
-                      <a:pPr algn="l" indent="0" marL="0">
+                      <a:pPr marL="0" indent="0" algn="l">
                         <a:buNone/>
                       </a:pPr>
                       <a:r>
@@ -4893,7 +4352,7 @@
                       </a:endParaRPr>
                     </a:p>
                   </a:txBody>
-                  <a:tcPr marL="91440" marR="91440" marT="45720" marB="45720" anchor="ctr">
+                  <a:tcPr anchor="ctr">
                     <a:lnL w="6350" cap="flat" cmpd="sng" algn="ctr">
                       <a:solidFill>
                         <a:srgbClr val="D8E2EA"/>
@@ -4940,7 +4399,7 @@
                     <a:bodyPr/>
                     <a:lstStyle/>
                     <a:p>
-                      <a:pPr algn="l" indent="0" marL="0">
+                      <a:pPr marL="0" indent="0" algn="l">
                         <a:buNone/>
                       </a:pPr>
                       <a:r>
@@ -4961,7 +4420,7 @@
                       </a:endParaRPr>
                     </a:p>
                   </a:txBody>
-                  <a:tcPr marL="91440" marR="91440" marT="45720" marB="45720" anchor="ctr">
+                  <a:tcPr anchor="ctr">
                     <a:lnL w="6350" cap="flat" cmpd="sng" algn="ctr">
                       <a:solidFill>
                         <a:srgbClr val="D8E2EA"/>
@@ -5008,7 +4467,7 @@
                     <a:bodyPr/>
                     <a:lstStyle/>
                     <a:p>
-                      <a:pPr algn="l" indent="0" marL="0">
+                      <a:pPr marL="0" indent="0" algn="l">
                         <a:buNone/>
                       </a:pPr>
                       <a:r>
@@ -5029,7 +4488,7 @@
                       </a:endParaRPr>
                     </a:p>
                   </a:txBody>
-                  <a:tcPr marL="91440" marR="91440" marT="45720" marB="45720" anchor="ctr">
+                  <a:tcPr anchor="ctr">
                     <a:lnL w="6350" cap="flat" cmpd="sng" algn="ctr">
                       <a:solidFill>
                         <a:srgbClr val="D8E2EA"/>
@@ -5076,7 +4535,7 @@
                     <a:bodyPr/>
                     <a:lstStyle/>
                     <a:p>
-                      <a:pPr algn="l" indent="0" marL="0">
+                      <a:pPr marL="0" indent="0" algn="l">
                         <a:buNone/>
                       </a:pPr>
                       <a:r>
@@ -5097,7 +4556,7 @@
                       </a:endParaRPr>
                     </a:p>
                   </a:txBody>
-                  <a:tcPr marL="91440" marR="91440" marT="45720" marB="45720" anchor="ctr">
+                  <a:tcPr anchor="ctr">
                     <a:lnL w="6350" cap="flat" cmpd="sng" algn="ctr">
                       <a:solidFill>
                         <a:srgbClr val="D8E2EA"/>
@@ -5139,6 +4598,11 @@
                     </a:solidFill>
                   </a:tcPr>
                 </a:tc>
+                <a:extLst>
+                  <a:ext uri="{0D108BD9-81ED-4DB2-BD59-A6C34878D82A}">
+                    <a16:rowId xmlns:a16="http://schemas.microsoft.com/office/drawing/2014/main" val="10000"/>
+                  </a:ext>
+                </a:extLst>
               </a:tr>
               <a:tr h="365760">
                 <a:tc>
@@ -5146,7 +4610,7 @@
                     <a:bodyPr/>
                     <a:lstStyle/>
                     <a:p>
-                      <a:pPr algn="l" indent="0" marL="0">
+                      <a:pPr marL="0" indent="0" algn="l">
                         <a:buNone/>
                       </a:pPr>
                       <a:r>
@@ -5167,7 +4631,7 @@
                       </a:endParaRPr>
                     </a:p>
                   </a:txBody>
-                  <a:tcPr marL="91440" marR="91440" marT="45720" marB="45720" anchor="ctr">
+                  <a:tcPr anchor="ctr">
                     <a:lnL w="6350" cap="flat" cmpd="sng" algn="ctr">
                       <a:solidFill>
                         <a:srgbClr val="D8E2EA"/>
@@ -5214,7 +4678,7 @@
                     <a:bodyPr/>
                     <a:lstStyle/>
                     <a:p>
-                      <a:pPr algn="l" indent="0" marL="0">
+                      <a:pPr marL="0" indent="0" algn="l">
                         <a:buNone/>
                       </a:pPr>
                       <a:r>
@@ -5235,7 +4699,7 @@
                       </a:endParaRPr>
                     </a:p>
                   </a:txBody>
-                  <a:tcPr marL="91440" marR="91440" marT="45720" marB="45720" anchor="ctr">
+                  <a:tcPr anchor="ctr">
                     <a:lnL w="6350" cap="flat" cmpd="sng" algn="ctr">
                       <a:solidFill>
                         <a:srgbClr val="D8E2EA"/>
@@ -5282,7 +4746,7 @@
                     <a:bodyPr/>
                     <a:lstStyle/>
                     <a:p>
-                      <a:pPr algn="l" indent="0" marL="0">
+                      <a:pPr marL="0" indent="0" algn="l">
                         <a:buNone/>
                       </a:pPr>
                       <a:r>
@@ -5303,7 +4767,7 @@
                       </a:endParaRPr>
                     </a:p>
                   </a:txBody>
-                  <a:tcPr marL="91440" marR="91440" marT="45720" marB="45720" anchor="ctr">
+                  <a:tcPr anchor="ctr">
                     <a:lnL w="6350" cap="flat" cmpd="sng" algn="ctr">
                       <a:solidFill>
                         <a:srgbClr val="D8E2EA"/>
@@ -5350,7 +4814,7 @@
                     <a:bodyPr/>
                     <a:lstStyle/>
                     <a:p>
-                      <a:pPr algn="l" indent="0" marL="0">
+                      <a:pPr marL="0" indent="0" algn="l">
                         <a:buNone/>
                       </a:pPr>
                       <a:r>
@@ -5371,7 +4835,7 @@
                       </a:endParaRPr>
                     </a:p>
                   </a:txBody>
-                  <a:tcPr marL="91440" marR="91440" marT="45720" marB="45720" anchor="ctr">
+                  <a:tcPr anchor="ctr">
                     <a:lnL w="6350" cap="flat" cmpd="sng" algn="ctr">
                       <a:solidFill>
                         <a:srgbClr val="D8E2EA"/>
@@ -5413,6 +4877,11 @@
                     </a:solidFill>
                   </a:tcPr>
                 </a:tc>
+                <a:extLst>
+                  <a:ext uri="{0D108BD9-81ED-4DB2-BD59-A6C34878D82A}">
+                    <a16:rowId xmlns:a16="http://schemas.microsoft.com/office/drawing/2014/main" val="10001"/>
+                  </a:ext>
+                </a:extLst>
               </a:tr>
               <a:tr h="365760">
                 <a:tc>
@@ -5420,7 +4889,7 @@
                     <a:bodyPr/>
                     <a:lstStyle/>
                     <a:p>
-                      <a:pPr algn="l" indent="0" marL="0">
+                      <a:pPr marL="0" indent="0" algn="l">
                         <a:buNone/>
                       </a:pPr>
                       <a:endParaRPr lang="en-US" sz="1200" dirty="0">
@@ -5430,7 +4899,7 @@
                       </a:endParaRPr>
                     </a:p>
                   </a:txBody>
-                  <a:tcPr marL="91440" marR="91440" marT="45720" marB="45720" anchor="ctr">
+                  <a:tcPr anchor="ctr">
                     <a:lnL w="6350" cap="flat" cmpd="sng" algn="ctr">
                       <a:solidFill>
                         <a:srgbClr val="D8E2EA"/>
@@ -5477,7 +4946,7 @@
                     <a:bodyPr/>
                     <a:lstStyle/>
                     <a:p>
-                      <a:pPr algn="l" indent="0" marL="0">
+                      <a:pPr marL="0" indent="0" algn="l">
                         <a:buNone/>
                       </a:pPr>
                       <a:r>
@@ -5498,7 +4967,7 @@
                       </a:endParaRPr>
                     </a:p>
                   </a:txBody>
-                  <a:tcPr marL="91440" marR="91440" marT="45720" marB="45720" anchor="ctr">
+                  <a:tcPr anchor="ctr">
                     <a:lnL w="6350" cap="flat" cmpd="sng" algn="ctr">
                       <a:solidFill>
                         <a:srgbClr val="D8E2EA"/>
@@ -5545,7 +5014,7 @@
                     <a:bodyPr/>
                     <a:lstStyle/>
                     <a:p>
-                      <a:pPr algn="l" indent="0" marL="0">
+                      <a:pPr marL="0" indent="0" algn="l">
                         <a:buNone/>
                       </a:pPr>
                       <a:r>
@@ -5566,7 +5035,7 @@
                       </a:endParaRPr>
                     </a:p>
                   </a:txBody>
-                  <a:tcPr marL="91440" marR="91440" marT="45720" marB="45720" anchor="ctr">
+                  <a:tcPr anchor="ctr">
                     <a:lnL w="6350" cap="flat" cmpd="sng" algn="ctr">
                       <a:solidFill>
                         <a:srgbClr val="D8E2EA"/>
@@ -5613,7 +5082,7 @@
                     <a:bodyPr/>
                     <a:lstStyle/>
                     <a:p>
-                      <a:pPr algn="l" indent="0" marL="0">
+                      <a:pPr marL="0" indent="0" algn="l">
                         <a:buNone/>
                       </a:pPr>
                       <a:r>
@@ -5634,7 +5103,7 @@
                       </a:endParaRPr>
                     </a:p>
                   </a:txBody>
-                  <a:tcPr marL="91440" marR="91440" marT="45720" marB="45720" anchor="ctr">
+                  <a:tcPr anchor="ctr">
                     <a:lnL w="6350" cap="flat" cmpd="sng" algn="ctr">
                       <a:solidFill>
                         <a:srgbClr val="D8E2EA"/>
@@ -5676,6 +5145,11 @@
                     </a:solidFill>
                   </a:tcPr>
                 </a:tc>
+                <a:extLst>
+                  <a:ext uri="{0D108BD9-81ED-4DB2-BD59-A6C34878D82A}">
+                    <a16:rowId xmlns:a16="http://schemas.microsoft.com/office/drawing/2014/main" val="10002"/>
+                  </a:ext>
+                </a:extLst>
               </a:tr>
               <a:tr h="365760">
                 <a:tc>
@@ -5683,7 +5157,7 @@
                     <a:bodyPr/>
                     <a:lstStyle/>
                     <a:p>
-                      <a:pPr algn="l" indent="0" marL="0">
+                      <a:pPr marL="0" indent="0" algn="l">
                         <a:buNone/>
                       </a:pPr>
                       <a:endParaRPr lang="en-US" sz="1200" dirty="0">
@@ -5693,7 +5167,7 @@
                       </a:endParaRPr>
                     </a:p>
                   </a:txBody>
-                  <a:tcPr marL="91440" marR="91440" marT="45720" marB="45720" anchor="ctr">
+                  <a:tcPr anchor="ctr">
                     <a:lnL w="6350" cap="flat" cmpd="sng" algn="ctr">
                       <a:solidFill>
                         <a:srgbClr val="D8E2EA"/>
@@ -5740,7 +5214,7 @@
                     <a:bodyPr/>
                     <a:lstStyle/>
                     <a:p>
-                      <a:pPr algn="l" indent="0" marL="0">
+                      <a:pPr marL="0" indent="0" algn="l">
                         <a:buNone/>
                       </a:pPr>
                       <a:r>
@@ -5761,7 +5235,7 @@
                       </a:endParaRPr>
                     </a:p>
                   </a:txBody>
-                  <a:tcPr marL="91440" marR="91440" marT="45720" marB="45720" anchor="ctr">
+                  <a:tcPr anchor="ctr">
                     <a:lnL w="6350" cap="flat" cmpd="sng" algn="ctr">
                       <a:solidFill>
                         <a:srgbClr val="D8E2EA"/>
@@ -5808,7 +5282,7 @@
                     <a:bodyPr/>
                     <a:lstStyle/>
                     <a:p>
-                      <a:pPr algn="l" indent="0" marL="0">
+                      <a:pPr marL="0" indent="0" algn="l">
                         <a:buNone/>
                       </a:pPr>
                       <a:r>
@@ -5829,7 +5303,7 @@
                       </a:endParaRPr>
                     </a:p>
                   </a:txBody>
-                  <a:tcPr marL="91440" marR="91440" marT="45720" marB="45720" anchor="ctr">
+                  <a:tcPr anchor="ctr">
                     <a:lnL w="6350" cap="flat" cmpd="sng" algn="ctr">
                       <a:solidFill>
                         <a:srgbClr val="D8E2EA"/>
@@ -5876,7 +5350,7 @@
                     <a:bodyPr/>
                     <a:lstStyle/>
                     <a:p>
-                      <a:pPr algn="l" indent="0" marL="0">
+                      <a:pPr marL="0" indent="0" algn="l">
                         <a:buNone/>
                       </a:pPr>
                       <a:r>
@@ -5897,7 +5371,7 @@
                       </a:endParaRPr>
                     </a:p>
                   </a:txBody>
-                  <a:tcPr marL="91440" marR="91440" marT="45720" marB="45720" anchor="ctr">
+                  <a:tcPr anchor="ctr">
                     <a:lnL w="6350" cap="flat" cmpd="sng" algn="ctr">
                       <a:solidFill>
                         <a:srgbClr val="D8E2EA"/>
@@ -5939,6 +5413,11 @@
                     </a:solidFill>
                   </a:tcPr>
                 </a:tc>
+                <a:extLst>
+                  <a:ext uri="{0D108BD9-81ED-4DB2-BD59-A6C34878D82A}">
+                    <a16:rowId xmlns:a16="http://schemas.microsoft.com/office/drawing/2014/main" val="10003"/>
+                  </a:ext>
+                </a:extLst>
               </a:tr>
               <a:tr h="365760">
                 <a:tc>
@@ -5946,7 +5425,7 @@
                     <a:bodyPr/>
                     <a:lstStyle/>
                     <a:p>
-                      <a:pPr algn="l" indent="0" marL="0">
+                      <a:pPr marL="0" indent="0" algn="l">
                         <a:buNone/>
                       </a:pPr>
                       <a:r>
@@ -5967,7 +5446,7 @@
                       </a:endParaRPr>
                     </a:p>
                     <a:p>
-                      <a:pPr algn="l" indent="0" marL="0">
+                      <a:pPr marL="0" indent="0" algn="l">
                         <a:buNone/>
                       </a:pPr>
                       <a:r>
@@ -5988,7 +5467,7 @@
                       </a:endParaRPr>
                     </a:p>
                   </a:txBody>
-                  <a:tcPr marL="91440" marR="91440" marT="45720" marB="45720" anchor="ctr">
+                  <a:tcPr anchor="ctr">
                     <a:lnL w="6350" cap="flat" cmpd="sng" algn="ctr">
                       <a:solidFill>
                         <a:srgbClr val="D8E2EA"/>
@@ -6035,7 +5514,7 @@
                     <a:bodyPr/>
                     <a:lstStyle/>
                     <a:p>
-                      <a:pPr algn="l" indent="0" marL="0">
+                      <a:pPr marL="0" indent="0" algn="l">
                         <a:buNone/>
                       </a:pPr>
                       <a:r>
@@ -6056,7 +5535,7 @@
                       </a:endParaRPr>
                     </a:p>
                   </a:txBody>
-                  <a:tcPr marL="91440" marR="91440" marT="45720" marB="45720" anchor="ctr">
+                  <a:tcPr anchor="ctr">
                     <a:lnL w="6350" cap="flat" cmpd="sng" algn="ctr">
                       <a:solidFill>
                         <a:srgbClr val="D8E2EA"/>
@@ -6103,7 +5582,7 @@
                     <a:bodyPr/>
                     <a:lstStyle/>
                     <a:p>
-                      <a:pPr algn="l" indent="0" marL="0">
+                      <a:pPr marL="0" indent="0" algn="l">
                         <a:buNone/>
                       </a:pPr>
                       <a:r>
@@ -6124,7 +5603,7 @@
                       </a:endParaRPr>
                     </a:p>
                   </a:txBody>
-                  <a:tcPr marL="91440" marR="91440" marT="45720" marB="45720" anchor="ctr">
+                  <a:tcPr anchor="ctr">
                     <a:lnL w="6350" cap="flat" cmpd="sng" algn="ctr">
                       <a:solidFill>
                         <a:srgbClr val="D8E2EA"/>
@@ -6171,7 +5650,7 @@
                     <a:bodyPr/>
                     <a:lstStyle/>
                     <a:p>
-                      <a:pPr algn="l" indent="0" marL="0">
+                      <a:pPr marL="0" indent="0" algn="l">
                         <a:buNone/>
                       </a:pPr>
                       <a:r>
@@ -6192,7 +5671,7 @@
                       </a:endParaRPr>
                     </a:p>
                   </a:txBody>
-                  <a:tcPr marL="91440" marR="91440" marT="45720" marB="45720" anchor="ctr">
+                  <a:tcPr anchor="ctr">
                     <a:lnL w="6350" cap="flat" cmpd="sng" algn="ctr">
                       <a:solidFill>
                         <a:srgbClr val="D8E2EA"/>
@@ -6234,6 +5713,11 @@
                     </a:solidFill>
                   </a:tcPr>
                 </a:tc>
+                <a:extLst>
+                  <a:ext uri="{0D108BD9-81ED-4DB2-BD59-A6C34878D82A}">
+                    <a16:rowId xmlns:a16="http://schemas.microsoft.com/office/drawing/2014/main" val="10004"/>
+                  </a:ext>
+                </a:extLst>
               </a:tr>
               <a:tr h="365760">
                 <a:tc>
@@ -6241,7 +5725,7 @@
                     <a:bodyPr/>
                     <a:lstStyle/>
                     <a:p>
-                      <a:pPr algn="l" indent="0" marL="0">
+                      <a:pPr marL="0" indent="0" algn="l">
                         <a:buNone/>
                       </a:pPr>
                       <a:endParaRPr lang="en-US" sz="1200" dirty="0">
@@ -6251,7 +5735,7 @@
                       </a:endParaRPr>
                     </a:p>
                   </a:txBody>
-                  <a:tcPr marL="91440" marR="91440" marT="45720" marB="45720" anchor="ctr">
+                  <a:tcPr anchor="ctr">
                     <a:lnL w="6350" cap="flat" cmpd="sng" algn="ctr">
                       <a:solidFill>
                         <a:srgbClr val="D8E2EA"/>
@@ -6298,7 +5782,7 @@
                     <a:bodyPr/>
                     <a:lstStyle/>
                     <a:p>
-                      <a:pPr algn="l" indent="0" marL="0">
+                      <a:pPr marL="0" indent="0" algn="l">
                         <a:buNone/>
                       </a:pPr>
                       <a:r>
@@ -6319,7 +5803,7 @@
                       </a:endParaRPr>
                     </a:p>
                   </a:txBody>
-                  <a:tcPr marL="91440" marR="91440" marT="45720" marB="45720" anchor="ctr">
+                  <a:tcPr anchor="ctr">
                     <a:lnL w="6350" cap="flat" cmpd="sng" algn="ctr">
                       <a:solidFill>
                         <a:srgbClr val="D8E2EA"/>
@@ -6366,7 +5850,7 @@
                     <a:bodyPr/>
                     <a:lstStyle/>
                     <a:p>
-                      <a:pPr algn="l" indent="0" marL="0">
+                      <a:pPr marL="0" indent="0" algn="l">
                         <a:buNone/>
                       </a:pPr>
                       <a:r>
@@ -6387,7 +5871,7 @@
                       </a:endParaRPr>
                     </a:p>
                   </a:txBody>
-                  <a:tcPr marL="91440" marR="91440" marT="45720" marB="45720" anchor="ctr">
+                  <a:tcPr anchor="ctr">
                     <a:lnL w="6350" cap="flat" cmpd="sng" algn="ctr">
                       <a:solidFill>
                         <a:srgbClr val="D8E2EA"/>
@@ -6434,7 +5918,7 @@
                     <a:bodyPr/>
                     <a:lstStyle/>
                     <a:p>
-                      <a:pPr algn="l" indent="0" marL="0">
+                      <a:pPr marL="0" indent="0" algn="l">
                         <a:buNone/>
                       </a:pPr>
                       <a:r>
@@ -6455,7 +5939,7 @@
                       </a:endParaRPr>
                     </a:p>
                   </a:txBody>
-                  <a:tcPr marL="91440" marR="91440" marT="45720" marB="45720" anchor="ctr">
+                  <a:tcPr anchor="ctr">
                     <a:lnL w="6350" cap="flat" cmpd="sng" algn="ctr">
                       <a:solidFill>
                         <a:srgbClr val="D8E2EA"/>
@@ -6497,6 +5981,11 @@
                     </a:solidFill>
                   </a:tcPr>
                 </a:tc>
+                <a:extLst>
+                  <a:ext uri="{0D108BD9-81ED-4DB2-BD59-A6C34878D82A}">
+                    <a16:rowId xmlns:a16="http://schemas.microsoft.com/office/drawing/2014/main" val="10005"/>
+                  </a:ext>
+                </a:extLst>
               </a:tr>
               <a:tr h="365760">
                 <a:tc>
@@ -6504,7 +5993,7 @@
                     <a:bodyPr/>
                     <a:lstStyle/>
                     <a:p>
-                      <a:pPr algn="l" indent="0" marL="0">
+                      <a:pPr marL="0" indent="0" algn="l">
                         <a:buNone/>
                       </a:pPr>
                       <a:endParaRPr lang="en-US" sz="1200" dirty="0">
@@ -6514,7 +6003,7 @@
                       </a:endParaRPr>
                     </a:p>
                   </a:txBody>
-                  <a:tcPr marL="91440" marR="91440" marT="45720" marB="45720" anchor="ctr">
+                  <a:tcPr anchor="ctr">
                     <a:lnL w="6350" cap="flat" cmpd="sng" algn="ctr">
                       <a:solidFill>
                         <a:srgbClr val="D8E2EA"/>
@@ -6561,7 +6050,7 @@
                     <a:bodyPr/>
                     <a:lstStyle/>
                     <a:p>
-                      <a:pPr algn="l" indent="0" marL="0">
+                      <a:pPr marL="0" indent="0" algn="l">
                         <a:buNone/>
                       </a:pPr>
                       <a:r>
@@ -6582,7 +6071,7 @@
                       </a:endParaRPr>
                     </a:p>
                   </a:txBody>
-                  <a:tcPr marL="91440" marR="91440" marT="45720" marB="45720" anchor="ctr">
+                  <a:tcPr anchor="ctr">
                     <a:lnL w="6350" cap="flat" cmpd="sng" algn="ctr">
                       <a:solidFill>
                         <a:srgbClr val="D8E2EA"/>
@@ -6629,7 +6118,7 @@
                     <a:bodyPr/>
                     <a:lstStyle/>
                     <a:p>
-                      <a:pPr algn="l" indent="0" marL="0">
+                      <a:pPr marL="0" indent="0" algn="l">
                         <a:buNone/>
                       </a:pPr>
                       <a:r>
@@ -6650,7 +6139,7 @@
                       </a:endParaRPr>
                     </a:p>
                   </a:txBody>
-                  <a:tcPr marL="91440" marR="91440" marT="45720" marB="45720" anchor="ctr">
+                  <a:tcPr anchor="ctr">
                     <a:lnL w="6350" cap="flat" cmpd="sng" algn="ctr">
                       <a:solidFill>
                         <a:srgbClr val="D8E2EA"/>
@@ -6697,7 +6186,7 @@
                     <a:bodyPr/>
                     <a:lstStyle/>
                     <a:p>
-                      <a:pPr algn="l" indent="0" marL="0">
+                      <a:pPr marL="0" indent="0" algn="l">
                         <a:buNone/>
                       </a:pPr>
                       <a:r>
@@ -6718,7 +6207,7 @@
                       </a:endParaRPr>
                     </a:p>
                   </a:txBody>
-                  <a:tcPr marL="91440" marR="91440" marT="45720" marB="45720" anchor="ctr">
+                  <a:tcPr anchor="ctr">
                     <a:lnL w="6350" cap="flat" cmpd="sng" algn="ctr">
                       <a:solidFill>
                         <a:srgbClr val="D8E2EA"/>
@@ -6760,6 +6249,11 @@
                     </a:solidFill>
                   </a:tcPr>
                 </a:tc>
+                <a:extLst>
+                  <a:ext uri="{0D108BD9-81ED-4DB2-BD59-A6C34878D82A}">
+                    <a16:rowId xmlns:a16="http://schemas.microsoft.com/office/drawing/2014/main" val="10006"/>
+                  </a:ext>
+                </a:extLst>
               </a:tr>
               <a:tr h="365760">
                 <a:tc>
@@ -6767,7 +6261,7 @@
                     <a:bodyPr/>
                     <a:lstStyle/>
                     <a:p>
-                      <a:pPr algn="l" indent="0" marL="0">
+                      <a:pPr marL="0" indent="0" algn="l">
                         <a:buNone/>
                       </a:pPr>
                       <a:endParaRPr lang="en-US" sz="1200" dirty="0">
@@ -6777,7 +6271,7 @@
                       </a:endParaRPr>
                     </a:p>
                   </a:txBody>
-                  <a:tcPr marL="91440" marR="91440" marT="45720" marB="45720" anchor="ctr">
+                  <a:tcPr anchor="ctr">
                     <a:lnL w="6350" cap="flat" cmpd="sng" algn="ctr">
                       <a:solidFill>
                         <a:srgbClr val="D8E2EA"/>
@@ -6824,7 +6318,7 @@
                     <a:bodyPr/>
                     <a:lstStyle/>
                     <a:p>
-                      <a:pPr algn="l" indent="0" marL="0">
+                      <a:pPr marL="0" indent="0" algn="l">
                         <a:buNone/>
                       </a:pPr>
                       <a:r>
@@ -6845,7 +6339,7 @@
                       </a:endParaRPr>
                     </a:p>
                   </a:txBody>
-                  <a:tcPr marL="91440" marR="91440" marT="45720" marB="45720" anchor="ctr">
+                  <a:tcPr anchor="ctr">
                     <a:lnL w="6350" cap="flat" cmpd="sng" algn="ctr">
                       <a:solidFill>
                         <a:srgbClr val="D8E2EA"/>
@@ -6892,7 +6386,7 @@
                     <a:bodyPr/>
                     <a:lstStyle/>
                     <a:p>
-                      <a:pPr algn="l" indent="0" marL="0">
+                      <a:pPr marL="0" indent="0" algn="l">
                         <a:buNone/>
                       </a:pPr>
                       <a:r>
@@ -6913,7 +6407,7 @@
                       </a:endParaRPr>
                     </a:p>
                   </a:txBody>
-                  <a:tcPr marL="91440" marR="91440" marT="45720" marB="45720" anchor="ctr">
+                  <a:tcPr anchor="ctr">
                     <a:lnL w="6350" cap="flat" cmpd="sng" algn="ctr">
                       <a:solidFill>
                         <a:srgbClr val="D8E2EA"/>
@@ -6960,7 +6454,7 @@
                     <a:bodyPr/>
                     <a:lstStyle/>
                     <a:p>
-                      <a:pPr algn="l" indent="0" marL="0">
+                      <a:pPr marL="0" indent="0" algn="l">
                         <a:buNone/>
                       </a:pPr>
                       <a:r>
@@ -6981,7 +6475,7 @@
                       </a:endParaRPr>
                     </a:p>
                   </a:txBody>
-                  <a:tcPr marL="91440" marR="91440" marT="45720" marB="45720" anchor="ctr">
+                  <a:tcPr anchor="ctr">
                     <a:lnL w="6350" cap="flat" cmpd="sng" algn="ctr">
                       <a:solidFill>
                         <a:srgbClr val="D8E2EA"/>
@@ -7023,6 +6517,11 @@
                     </a:solidFill>
                   </a:tcPr>
                 </a:tc>
+                <a:extLst>
+                  <a:ext uri="{0D108BD9-81ED-4DB2-BD59-A6C34878D82A}">
+                    <a16:rowId xmlns:a16="http://schemas.microsoft.com/office/drawing/2014/main" val="10007"/>
+                  </a:ext>
+                </a:extLst>
               </a:tr>
             </a:tbl>
           </a:graphicData>
@@ -7049,7 +6548,7 @@
           <a:bodyPr wrap="square" lIns="0" tIns="0" rIns="0" bIns="0" rtlCol="0" anchor="ctr"/>
           <a:lstStyle/>
           <a:p>
-            <a:pPr indent="0" marL="0">
+            <a:pPr marL="0" indent="0">
               <a:buNone/>
             </a:pPr>
             <a:r>
@@ -7063,9 +6562,6 @@
               </a:rPr>
               <a:t>Direção:  </a:t>
             </a:r>
-            <a:pPr indent="0" marL="0">
-              <a:buNone/>
-            </a:pPr>
             <a:r>
               <a:rPr lang="en-US" sz="1150" i="1" dirty="0">
                 <a:solidFill>
@@ -7097,6 +6593,7 @@
         <a:solidFill>
           <a:srgbClr val="FFFFFF"/>
         </a:solidFill>
+        <a:effectLst/>
       </p:bgPr>
     </p:bg>
     <p:spTree>
@@ -7134,11 +6631,11 @@
           <a:bodyPr wrap="square" lIns="0" tIns="0" rIns="0" bIns="0" rtlCol="0" anchor="ctr"/>
           <a:lstStyle/>
           <a:p>
-            <a:pPr indent="0" marL="0">
+            <a:pPr marL="0" indent="0">
               <a:buNone/>
             </a:pPr>
             <a:r>
-              <a:rPr lang="en-US" sz="1100" b="1" spc="200" kern="0" dirty="0">
+              <a:rPr lang="en-US" sz="1100" b="1" kern="0" spc="200" dirty="0">
                 <a:solidFill>
                   <a:srgbClr val="1C7293"/>
                 </a:solidFill>
@@ -7173,7 +6670,7 @@
           <a:bodyPr wrap="square" lIns="0" tIns="0" rIns="0" bIns="0" rtlCol="0" anchor="ctr"/>
           <a:lstStyle/>
           <a:p>
-            <a:pPr indent="0" marL="0">
+            <a:pPr marL="0" indent="0">
               <a:buNone/>
             </a:pPr>
             <a:r>
@@ -7207,20 +6704,62 @@
         </p:nvGraphicFramePr>
         <p:xfrm>
           <a:off x="457200" y="1234440"/>
-          <a:ext cx="8229600" cy="914400"/>
+          <a:ext cx="8229600" cy="2926080"/>
         </p:xfrm>
         <a:graphic>
           <a:graphicData uri="http://schemas.openxmlformats.org/drawingml/2006/table">
             <a:tbl>
               <a:tblPr/>
               <a:tblGrid>
-                <a:gridCol w="2377440"/>
-                <a:gridCol w="1051560"/>
-                <a:gridCol w="960120"/>
-                <a:gridCol w="1234440"/>
-                <a:gridCol w="868680"/>
-                <a:gridCol w="868680"/>
-                <a:gridCol w="868680"/>
+                <a:gridCol w="2377440">
+                  <a:extLst>
+                    <a:ext uri="{9D8B030D-6E8A-4147-A177-3AD203B41FA5}">
+                      <a16:colId xmlns:a16="http://schemas.microsoft.com/office/drawing/2014/main" val="20000"/>
+                    </a:ext>
+                  </a:extLst>
+                </a:gridCol>
+                <a:gridCol w="1051560">
+                  <a:extLst>
+                    <a:ext uri="{9D8B030D-6E8A-4147-A177-3AD203B41FA5}">
+                      <a16:colId xmlns:a16="http://schemas.microsoft.com/office/drawing/2014/main" val="20001"/>
+                    </a:ext>
+                  </a:extLst>
+                </a:gridCol>
+                <a:gridCol w="960120">
+                  <a:extLst>
+                    <a:ext uri="{9D8B030D-6E8A-4147-A177-3AD203B41FA5}">
+                      <a16:colId xmlns:a16="http://schemas.microsoft.com/office/drawing/2014/main" val="20002"/>
+                    </a:ext>
+                  </a:extLst>
+                </a:gridCol>
+                <a:gridCol w="1234440">
+                  <a:extLst>
+                    <a:ext uri="{9D8B030D-6E8A-4147-A177-3AD203B41FA5}">
+                      <a16:colId xmlns:a16="http://schemas.microsoft.com/office/drawing/2014/main" val="20003"/>
+                    </a:ext>
+                  </a:extLst>
+                </a:gridCol>
+                <a:gridCol w="868680">
+                  <a:extLst>
+                    <a:ext uri="{9D8B030D-6E8A-4147-A177-3AD203B41FA5}">
+                      <a16:colId xmlns:a16="http://schemas.microsoft.com/office/drawing/2014/main" val="20004"/>
+                    </a:ext>
+                  </a:extLst>
+                </a:gridCol>
+                <a:gridCol w="868680">
+                  <a:extLst>
+                    <a:ext uri="{9D8B030D-6E8A-4147-A177-3AD203B41FA5}">
+                      <a16:colId xmlns:a16="http://schemas.microsoft.com/office/drawing/2014/main" val="20005"/>
+                    </a:ext>
+                  </a:extLst>
+                </a:gridCol>
+                <a:gridCol w="868680">
+                  <a:extLst>
+                    <a:ext uri="{9D8B030D-6E8A-4147-A177-3AD203B41FA5}">
+                      <a16:colId xmlns:a16="http://schemas.microsoft.com/office/drawing/2014/main" val="20006"/>
+                    </a:ext>
+                  </a:extLst>
+                </a:gridCol>
               </a:tblGrid>
               <a:tr h="365760">
                 <a:tc>
@@ -7228,7 +6767,7 @@
                     <a:bodyPr/>
                     <a:lstStyle/>
                     <a:p>
-                      <a:pPr algn="ctr" indent="0" marL="0">
+                      <a:pPr marL="0" indent="0" algn="ctr">
                         <a:buNone/>
                       </a:pPr>
                       <a:r>
@@ -7249,7 +6788,7 @@
                       </a:endParaRPr>
                     </a:p>
                   </a:txBody>
-                  <a:tcPr marL="91440" marR="91440" marT="45720" marB="45720" anchor="ctr">
+                  <a:tcPr anchor="ctr">
                     <a:lnL w="6350" cap="flat" cmpd="sng" algn="ctr">
                       <a:solidFill>
                         <a:srgbClr val="D8E2EA"/>
@@ -7296,7 +6835,7 @@
                     <a:bodyPr/>
                     <a:lstStyle/>
                     <a:p>
-                      <a:pPr algn="ctr" indent="0" marL="0">
+                      <a:pPr marL="0" indent="0" algn="ctr">
                         <a:buNone/>
                       </a:pPr>
                       <a:r>
@@ -7317,7 +6856,7 @@
                       </a:endParaRPr>
                     </a:p>
                   </a:txBody>
-                  <a:tcPr marL="91440" marR="91440" marT="45720" marB="45720" anchor="ctr">
+                  <a:tcPr anchor="ctr">
                     <a:lnL w="6350" cap="flat" cmpd="sng" algn="ctr">
                       <a:solidFill>
                         <a:srgbClr val="D8E2EA"/>
@@ -7364,7 +6903,7 @@
                     <a:bodyPr/>
                     <a:lstStyle/>
                     <a:p>
-                      <a:pPr algn="ctr" indent="0" marL="0">
+                      <a:pPr marL="0" indent="0" algn="ctr">
                         <a:buNone/>
                       </a:pPr>
                       <a:r>
@@ -7385,7 +6924,7 @@
                       </a:endParaRPr>
                     </a:p>
                   </a:txBody>
-                  <a:tcPr marL="91440" marR="91440" marT="45720" marB="45720" anchor="ctr">
+                  <a:tcPr anchor="ctr">
                     <a:lnL w="6350" cap="flat" cmpd="sng" algn="ctr">
                       <a:solidFill>
                         <a:srgbClr val="D8E2EA"/>
@@ -7432,7 +6971,7 @@
                     <a:bodyPr/>
                     <a:lstStyle/>
                     <a:p>
-                      <a:pPr algn="ctr" indent="0" marL="0">
+                      <a:pPr marL="0" indent="0" algn="ctr">
                         <a:buNone/>
                       </a:pPr>
                       <a:r>
@@ -7453,7 +6992,7 @@
                       </a:endParaRPr>
                     </a:p>
                   </a:txBody>
-                  <a:tcPr marL="91440" marR="91440" marT="45720" marB="45720" anchor="ctr">
+                  <a:tcPr anchor="ctr">
                     <a:lnL w="6350" cap="flat" cmpd="sng" algn="ctr">
                       <a:solidFill>
                         <a:srgbClr val="D8E2EA"/>
@@ -7500,7 +7039,7 @@
                     <a:bodyPr/>
                     <a:lstStyle/>
                     <a:p>
-                      <a:pPr algn="ctr" indent="0" marL="0">
+                      <a:pPr marL="0" indent="0" algn="ctr">
                         <a:buNone/>
                       </a:pPr>
                       <a:r>
@@ -7521,7 +7060,7 @@
                       </a:endParaRPr>
                     </a:p>
                   </a:txBody>
-                  <a:tcPr marL="91440" marR="91440" marT="45720" marB="45720" anchor="ctr">
+                  <a:tcPr anchor="ctr">
                     <a:lnL w="6350" cap="flat" cmpd="sng" algn="ctr">
                       <a:solidFill>
                         <a:srgbClr val="D8E2EA"/>
@@ -7568,7 +7107,7 @@
                     <a:bodyPr/>
                     <a:lstStyle/>
                     <a:p>
-                      <a:pPr algn="ctr" indent="0" marL="0">
+                      <a:pPr marL="0" indent="0" algn="ctr">
                         <a:buNone/>
                       </a:pPr>
                       <a:r>
@@ -7589,7 +7128,7 @@
                       </a:endParaRPr>
                     </a:p>
                   </a:txBody>
-                  <a:tcPr marL="91440" marR="91440" marT="45720" marB="45720" anchor="ctr">
+                  <a:tcPr anchor="ctr">
                     <a:lnL w="6350" cap="flat" cmpd="sng" algn="ctr">
                       <a:solidFill>
                         <a:srgbClr val="D8E2EA"/>
@@ -7636,7 +7175,7 @@
                     <a:bodyPr/>
                     <a:lstStyle/>
                     <a:p>
-                      <a:pPr algn="ctr" indent="0" marL="0">
+                      <a:pPr marL="0" indent="0" algn="ctr">
                         <a:buNone/>
                       </a:pPr>
                       <a:r>
@@ -7657,7 +7196,7 @@
                       </a:endParaRPr>
                     </a:p>
                   </a:txBody>
-                  <a:tcPr marL="91440" marR="91440" marT="45720" marB="45720" anchor="ctr">
+                  <a:tcPr anchor="ctr">
                     <a:lnL w="6350" cap="flat" cmpd="sng" algn="ctr">
                       <a:solidFill>
                         <a:srgbClr val="D8E2EA"/>
@@ -7699,6 +7238,11 @@
                     </a:solidFill>
                   </a:tcPr>
                 </a:tc>
+                <a:extLst>
+                  <a:ext uri="{0D108BD9-81ED-4DB2-BD59-A6C34878D82A}">
+                    <a16:rowId xmlns:a16="http://schemas.microsoft.com/office/drawing/2014/main" val="10000"/>
+                  </a:ext>
+                </a:extLst>
               </a:tr>
               <a:tr h="365760">
                 <a:tc>
@@ -7706,7 +7250,7 @@
                     <a:bodyPr/>
                     <a:lstStyle/>
                     <a:p>
-                      <a:pPr algn="l" indent="0" marL="0">
+                      <a:pPr marL="0" indent="0" algn="l">
                         <a:buNone/>
                       </a:pPr>
                       <a:r>
@@ -7727,7 +7271,7 @@
                       </a:endParaRPr>
                     </a:p>
                   </a:txBody>
-                  <a:tcPr marL="91440" marR="91440" marT="45720" marB="45720" anchor="ctr">
+                  <a:tcPr anchor="ctr">
                     <a:lnL w="6350" cap="flat" cmpd="sng" algn="ctr">
                       <a:solidFill>
                         <a:srgbClr val="D8E2EA"/>
@@ -7774,7 +7318,7 @@
                     <a:bodyPr/>
                     <a:lstStyle/>
                     <a:p>
-                      <a:pPr algn="ctr" indent="0" marL="0">
+                      <a:pPr marL="0" indent="0" algn="ctr">
                         <a:buNone/>
                       </a:pPr>
                       <a:r>
@@ -7795,7 +7339,7 @@
                       </a:endParaRPr>
                     </a:p>
                   </a:txBody>
-                  <a:tcPr marL="91440" marR="91440" marT="45720" marB="45720" anchor="ctr">
+                  <a:tcPr anchor="ctr">
                     <a:lnL w="6350" cap="flat" cmpd="sng" algn="ctr">
                       <a:solidFill>
                         <a:srgbClr val="D8E2EA"/>
@@ -7842,7 +7386,7 @@
                     <a:bodyPr/>
                     <a:lstStyle/>
                     <a:p>
-                      <a:pPr algn="ctr" indent="0" marL="0">
+                      <a:pPr marL="0" indent="0" algn="ctr">
                         <a:buNone/>
                       </a:pPr>
                       <a:r>
@@ -7863,7 +7407,7 @@
                       </a:endParaRPr>
                     </a:p>
                   </a:txBody>
-                  <a:tcPr marL="91440" marR="91440" marT="45720" marB="45720" anchor="ctr">
+                  <a:tcPr anchor="ctr">
                     <a:lnL w="6350" cap="flat" cmpd="sng" algn="ctr">
                       <a:solidFill>
                         <a:srgbClr val="D8E2EA"/>
@@ -7910,7 +7454,7 @@
                     <a:bodyPr/>
                     <a:lstStyle/>
                     <a:p>
-                      <a:pPr algn="ctr" indent="0" marL="0">
+                      <a:pPr marL="0" indent="0" algn="ctr">
                         <a:buNone/>
                       </a:pPr>
                       <a:r>
@@ -7931,7 +7475,7 @@
                       </a:endParaRPr>
                     </a:p>
                   </a:txBody>
-                  <a:tcPr marL="91440" marR="91440" marT="45720" marB="45720" anchor="ctr">
+                  <a:tcPr anchor="ctr">
                     <a:lnL w="6350" cap="flat" cmpd="sng" algn="ctr">
                       <a:solidFill>
                         <a:srgbClr val="D8E2EA"/>
@@ -7978,7 +7522,7 @@
                     <a:bodyPr/>
                     <a:lstStyle/>
                     <a:p>
-                      <a:pPr algn="ctr" indent="0" marL="0">
+                      <a:pPr marL="0" indent="0" algn="ctr">
                         <a:buNone/>
                       </a:pPr>
                       <a:r>
@@ -7999,7 +7543,7 @@
                       </a:endParaRPr>
                     </a:p>
                   </a:txBody>
-                  <a:tcPr marL="91440" marR="91440" marT="45720" marB="45720" anchor="ctr">
+                  <a:tcPr anchor="ctr">
                     <a:lnL w="6350" cap="flat" cmpd="sng" algn="ctr">
                       <a:solidFill>
                         <a:srgbClr val="D8E2EA"/>
@@ -8046,7 +7590,7 @@
                     <a:bodyPr/>
                     <a:lstStyle/>
                     <a:p>
-                      <a:pPr algn="ctr" indent="0" marL="0">
+                      <a:pPr marL="0" indent="0" algn="ctr">
                         <a:buNone/>
                       </a:pPr>
                       <a:r>
@@ -8067,7 +7611,7 @@
                       </a:endParaRPr>
                     </a:p>
                   </a:txBody>
-                  <a:tcPr marL="91440" marR="91440" marT="45720" marB="45720" anchor="ctr">
+                  <a:tcPr anchor="ctr">
                     <a:lnL w="6350" cap="flat" cmpd="sng" algn="ctr">
                       <a:solidFill>
                         <a:srgbClr val="D8E2EA"/>
@@ -8114,7 +7658,7 @@
                     <a:bodyPr/>
                     <a:lstStyle/>
                     <a:p>
-                      <a:pPr algn="ctr" indent="0" marL="0">
+                      <a:pPr marL="0" indent="0" algn="ctr">
                         <a:buNone/>
                       </a:pPr>
                       <a:r>
@@ -8135,7 +7679,7 @@
                       </a:endParaRPr>
                     </a:p>
                   </a:txBody>
-                  <a:tcPr marL="91440" marR="91440" marT="45720" marB="45720" anchor="ctr">
+                  <a:tcPr anchor="ctr">
                     <a:lnL w="6350" cap="flat" cmpd="sng" algn="ctr">
                       <a:solidFill>
                         <a:srgbClr val="D8E2EA"/>
@@ -8177,6 +7721,11 @@
                     </a:solidFill>
                   </a:tcPr>
                 </a:tc>
+                <a:extLst>
+                  <a:ext uri="{0D108BD9-81ED-4DB2-BD59-A6C34878D82A}">
+                    <a16:rowId xmlns:a16="http://schemas.microsoft.com/office/drawing/2014/main" val="10001"/>
+                  </a:ext>
+                </a:extLst>
               </a:tr>
               <a:tr h="365760">
                 <a:tc>
@@ -8184,7 +7733,7 @@
                     <a:bodyPr/>
                     <a:lstStyle/>
                     <a:p>
-                      <a:pPr algn="l" indent="0" marL="0">
+                      <a:pPr marL="0" indent="0" algn="l">
                         <a:buNone/>
                       </a:pPr>
                       <a:r>
@@ -8205,7 +7754,7 @@
                       </a:endParaRPr>
                     </a:p>
                   </a:txBody>
-                  <a:tcPr marL="91440" marR="91440" marT="45720" marB="45720" anchor="ctr">
+                  <a:tcPr anchor="ctr">
                     <a:lnL w="6350" cap="flat" cmpd="sng" algn="ctr">
                       <a:solidFill>
                         <a:srgbClr val="D8E2EA"/>
@@ -8252,7 +7801,7 @@
                     <a:bodyPr/>
                     <a:lstStyle/>
                     <a:p>
-                      <a:pPr algn="ctr" indent="0" marL="0">
+                      <a:pPr marL="0" indent="0" algn="ctr">
                         <a:buNone/>
                       </a:pPr>
                       <a:r>
@@ -8273,7 +7822,7 @@
                       </a:endParaRPr>
                     </a:p>
                   </a:txBody>
-                  <a:tcPr marL="91440" marR="91440" marT="45720" marB="45720" anchor="ctr">
+                  <a:tcPr anchor="ctr">
                     <a:lnL w="6350" cap="flat" cmpd="sng" algn="ctr">
                       <a:solidFill>
                         <a:srgbClr val="D8E2EA"/>
@@ -8320,7 +7869,7 @@
                     <a:bodyPr/>
                     <a:lstStyle/>
                     <a:p>
-                      <a:pPr algn="ctr" indent="0" marL="0">
+                      <a:pPr marL="0" indent="0" algn="ctr">
                         <a:buNone/>
                       </a:pPr>
                       <a:r>
@@ -8341,7 +7890,7 @@
                       </a:endParaRPr>
                     </a:p>
                   </a:txBody>
-                  <a:tcPr marL="91440" marR="91440" marT="45720" marB="45720" anchor="ctr">
+                  <a:tcPr anchor="ctr">
                     <a:lnL w="6350" cap="flat" cmpd="sng" algn="ctr">
                       <a:solidFill>
                         <a:srgbClr val="D8E2EA"/>
@@ -8388,7 +7937,7 @@
                     <a:bodyPr/>
                     <a:lstStyle/>
                     <a:p>
-                      <a:pPr algn="ctr" indent="0" marL="0">
+                      <a:pPr marL="0" indent="0" algn="ctr">
                         <a:buNone/>
                       </a:pPr>
                       <a:r>
@@ -8409,7 +7958,7 @@
                       </a:endParaRPr>
                     </a:p>
                   </a:txBody>
-                  <a:tcPr marL="91440" marR="91440" marT="45720" marB="45720" anchor="ctr">
+                  <a:tcPr anchor="ctr">
                     <a:lnL w="6350" cap="flat" cmpd="sng" algn="ctr">
                       <a:solidFill>
                         <a:srgbClr val="D8E2EA"/>
@@ -8456,7 +8005,7 @@
                     <a:bodyPr/>
                     <a:lstStyle/>
                     <a:p>
-                      <a:pPr algn="ctr" indent="0" marL="0">
+                      <a:pPr marL="0" indent="0" algn="ctr">
                         <a:buNone/>
                       </a:pPr>
                       <a:r>
@@ -8477,7 +8026,7 @@
                       </a:endParaRPr>
                     </a:p>
                   </a:txBody>
-                  <a:tcPr marL="91440" marR="91440" marT="45720" marB="45720" anchor="ctr">
+                  <a:tcPr anchor="ctr">
                     <a:lnL w="6350" cap="flat" cmpd="sng" algn="ctr">
                       <a:solidFill>
                         <a:srgbClr val="D8E2EA"/>
@@ -8524,7 +8073,7 @@
                     <a:bodyPr/>
                     <a:lstStyle/>
                     <a:p>
-                      <a:pPr algn="ctr" indent="0" marL="0">
+                      <a:pPr marL="0" indent="0" algn="ctr">
                         <a:buNone/>
                       </a:pPr>
                       <a:r>
@@ -8545,7 +8094,7 @@
                       </a:endParaRPr>
                     </a:p>
                   </a:txBody>
-                  <a:tcPr marL="91440" marR="91440" marT="45720" marB="45720" anchor="ctr">
+                  <a:tcPr anchor="ctr">
                     <a:lnL w="6350" cap="flat" cmpd="sng" algn="ctr">
                       <a:solidFill>
                         <a:srgbClr val="D8E2EA"/>
@@ -8592,7 +8141,7 @@
                     <a:bodyPr/>
                     <a:lstStyle/>
                     <a:p>
-                      <a:pPr algn="ctr" indent="0" marL="0">
+                      <a:pPr marL="0" indent="0" algn="ctr">
                         <a:buNone/>
                       </a:pPr>
                       <a:r>
@@ -8613,7 +8162,7 @@
                       </a:endParaRPr>
                     </a:p>
                   </a:txBody>
-                  <a:tcPr marL="91440" marR="91440" marT="45720" marB="45720" anchor="ctr">
+                  <a:tcPr anchor="ctr">
                     <a:lnL w="6350" cap="flat" cmpd="sng" algn="ctr">
                       <a:solidFill>
                         <a:srgbClr val="D8E2EA"/>
@@ -8655,6 +8204,11 @@
                     </a:solidFill>
                   </a:tcPr>
                 </a:tc>
+                <a:extLst>
+                  <a:ext uri="{0D108BD9-81ED-4DB2-BD59-A6C34878D82A}">
+                    <a16:rowId xmlns:a16="http://schemas.microsoft.com/office/drawing/2014/main" val="10002"/>
+                  </a:ext>
+                </a:extLst>
               </a:tr>
               <a:tr h="365760">
                 <a:tc>
@@ -8662,7 +8216,7 @@
                     <a:bodyPr/>
                     <a:lstStyle/>
                     <a:p>
-                      <a:pPr algn="l" indent="0" marL="0">
+                      <a:pPr marL="0" indent="0" algn="l">
                         <a:buNone/>
                       </a:pPr>
                       <a:r>
@@ -8683,7 +8237,7 @@
                       </a:endParaRPr>
                     </a:p>
                   </a:txBody>
-                  <a:tcPr marL="91440" marR="91440" marT="45720" marB="45720" anchor="ctr">
+                  <a:tcPr anchor="ctr">
                     <a:lnL w="6350" cap="flat" cmpd="sng" algn="ctr">
                       <a:solidFill>
                         <a:srgbClr val="D8E2EA"/>
@@ -8730,7 +8284,7 @@
                     <a:bodyPr/>
                     <a:lstStyle/>
                     <a:p>
-                      <a:pPr algn="ctr" indent="0" marL="0">
+                      <a:pPr marL="0" indent="0" algn="ctr">
                         <a:buNone/>
                       </a:pPr>
                       <a:r>
@@ -8751,7 +8305,7 @@
                       </a:endParaRPr>
                     </a:p>
                   </a:txBody>
-                  <a:tcPr marL="91440" marR="91440" marT="45720" marB="45720" anchor="ctr">
+                  <a:tcPr anchor="ctr">
                     <a:lnL w="6350" cap="flat" cmpd="sng" algn="ctr">
                       <a:solidFill>
                         <a:srgbClr val="D8E2EA"/>
@@ -8798,7 +8352,7 @@
                     <a:bodyPr/>
                     <a:lstStyle/>
                     <a:p>
-                      <a:pPr algn="ctr" indent="0" marL="0">
+                      <a:pPr marL="0" indent="0" algn="ctr">
                         <a:buNone/>
                       </a:pPr>
                       <a:r>
@@ -8819,7 +8373,7 @@
                       </a:endParaRPr>
                     </a:p>
                   </a:txBody>
-                  <a:tcPr marL="91440" marR="91440" marT="45720" marB="45720" anchor="ctr">
+                  <a:tcPr anchor="ctr">
                     <a:lnL w="6350" cap="flat" cmpd="sng" algn="ctr">
                       <a:solidFill>
                         <a:srgbClr val="D8E2EA"/>
@@ -8866,7 +8420,7 @@
                     <a:bodyPr/>
                     <a:lstStyle/>
                     <a:p>
-                      <a:pPr algn="ctr" indent="0" marL="0">
+                      <a:pPr marL="0" indent="0" algn="ctr">
                         <a:buNone/>
                       </a:pPr>
                       <a:r>
@@ -8887,7 +8441,7 @@
                       </a:endParaRPr>
                     </a:p>
                   </a:txBody>
-                  <a:tcPr marL="91440" marR="91440" marT="45720" marB="45720" anchor="ctr">
+                  <a:tcPr anchor="ctr">
                     <a:lnL w="6350" cap="flat" cmpd="sng" algn="ctr">
                       <a:solidFill>
                         <a:srgbClr val="D8E2EA"/>
@@ -8934,7 +8488,7 @@
                     <a:bodyPr/>
                     <a:lstStyle/>
                     <a:p>
-                      <a:pPr algn="ctr" indent="0" marL="0">
+                      <a:pPr marL="0" indent="0" algn="ctr">
                         <a:buNone/>
                       </a:pPr>
                       <a:r>
@@ -8955,7 +8509,7 @@
                       </a:endParaRPr>
                     </a:p>
                   </a:txBody>
-                  <a:tcPr marL="91440" marR="91440" marT="45720" marB="45720" anchor="ctr">
+                  <a:tcPr anchor="ctr">
                     <a:lnL w="6350" cap="flat" cmpd="sng" algn="ctr">
                       <a:solidFill>
                         <a:srgbClr val="D8E2EA"/>
@@ -9002,7 +8556,7 @@
                     <a:bodyPr/>
                     <a:lstStyle/>
                     <a:p>
-                      <a:pPr algn="ctr" indent="0" marL="0">
+                      <a:pPr marL="0" indent="0" algn="ctr">
                         <a:buNone/>
                       </a:pPr>
                       <a:r>
@@ -9023,7 +8577,7 @@
                       </a:endParaRPr>
                     </a:p>
                   </a:txBody>
-                  <a:tcPr marL="91440" marR="91440" marT="45720" marB="45720" anchor="ctr">
+                  <a:tcPr anchor="ctr">
                     <a:lnL w="6350" cap="flat" cmpd="sng" algn="ctr">
                       <a:solidFill>
                         <a:srgbClr val="D8E2EA"/>
@@ -9070,7 +8624,7 @@
                     <a:bodyPr/>
                     <a:lstStyle/>
                     <a:p>
-                      <a:pPr algn="ctr" indent="0" marL="0">
+                      <a:pPr marL="0" indent="0" algn="ctr">
                         <a:buNone/>
                       </a:pPr>
                       <a:r>
@@ -9091,7 +8645,7 @@
                       </a:endParaRPr>
                     </a:p>
                   </a:txBody>
-                  <a:tcPr marL="91440" marR="91440" marT="45720" marB="45720" anchor="ctr">
+                  <a:tcPr anchor="ctr">
                     <a:lnL w="6350" cap="flat" cmpd="sng" algn="ctr">
                       <a:solidFill>
                         <a:srgbClr val="D8E2EA"/>
@@ -9133,6 +8687,11 @@
                     </a:solidFill>
                   </a:tcPr>
                 </a:tc>
+                <a:extLst>
+                  <a:ext uri="{0D108BD9-81ED-4DB2-BD59-A6C34878D82A}">
+                    <a16:rowId xmlns:a16="http://schemas.microsoft.com/office/drawing/2014/main" val="10003"/>
+                  </a:ext>
+                </a:extLst>
               </a:tr>
               <a:tr h="365760">
                 <a:tc>
@@ -9140,7 +8699,7 @@
                     <a:bodyPr/>
                     <a:lstStyle/>
                     <a:p>
-                      <a:pPr algn="l" indent="0" marL="0">
+                      <a:pPr marL="0" indent="0" algn="l">
                         <a:buNone/>
                       </a:pPr>
                       <a:r>
@@ -9161,7 +8720,7 @@
                       </a:endParaRPr>
                     </a:p>
                   </a:txBody>
-                  <a:tcPr marL="91440" marR="91440" marT="45720" marB="45720" anchor="ctr">
+                  <a:tcPr anchor="ctr">
                     <a:lnL w="6350" cap="flat" cmpd="sng" algn="ctr">
                       <a:solidFill>
                         <a:srgbClr val="D8E2EA"/>
@@ -9208,7 +8767,7 @@
                     <a:bodyPr/>
                     <a:lstStyle/>
                     <a:p>
-                      <a:pPr algn="ctr" indent="0" marL="0">
+                      <a:pPr marL="0" indent="0" algn="ctr">
                         <a:buNone/>
                       </a:pPr>
                       <a:r>
@@ -9229,7 +8788,7 @@
                       </a:endParaRPr>
                     </a:p>
                   </a:txBody>
-                  <a:tcPr marL="91440" marR="91440" marT="45720" marB="45720" anchor="ctr">
+                  <a:tcPr anchor="ctr">
                     <a:lnL w="6350" cap="flat" cmpd="sng" algn="ctr">
                       <a:solidFill>
                         <a:srgbClr val="D8E2EA"/>
@@ -9276,7 +8835,7 @@
                     <a:bodyPr/>
                     <a:lstStyle/>
                     <a:p>
-                      <a:pPr algn="ctr" indent="0" marL="0">
+                      <a:pPr marL="0" indent="0" algn="ctr">
                         <a:buNone/>
                       </a:pPr>
                       <a:r>
@@ -9297,7 +8856,7 @@
                       </a:endParaRPr>
                     </a:p>
                   </a:txBody>
-                  <a:tcPr marL="91440" marR="91440" marT="45720" marB="45720" anchor="ctr">
+                  <a:tcPr anchor="ctr">
                     <a:lnL w="6350" cap="flat" cmpd="sng" algn="ctr">
                       <a:solidFill>
                         <a:srgbClr val="D8E2EA"/>
@@ -9344,7 +8903,7 @@
                     <a:bodyPr/>
                     <a:lstStyle/>
                     <a:p>
-                      <a:pPr algn="ctr" indent="0" marL="0">
+                      <a:pPr marL="0" indent="0" algn="ctr">
                         <a:buNone/>
                       </a:pPr>
                       <a:r>
@@ -9365,7 +8924,7 @@
                       </a:endParaRPr>
                     </a:p>
                   </a:txBody>
-                  <a:tcPr marL="91440" marR="91440" marT="45720" marB="45720" anchor="ctr">
+                  <a:tcPr anchor="ctr">
                     <a:lnL w="6350" cap="flat" cmpd="sng" algn="ctr">
                       <a:solidFill>
                         <a:srgbClr val="D8E2EA"/>
@@ -9412,7 +8971,7 @@
                     <a:bodyPr/>
                     <a:lstStyle/>
                     <a:p>
-                      <a:pPr algn="ctr" indent="0" marL="0">
+                      <a:pPr marL="0" indent="0" algn="ctr">
                         <a:buNone/>
                       </a:pPr>
                       <a:r>
@@ -9433,7 +8992,7 @@
                       </a:endParaRPr>
                     </a:p>
                   </a:txBody>
-                  <a:tcPr marL="91440" marR="91440" marT="45720" marB="45720" anchor="ctr">
+                  <a:tcPr anchor="ctr">
                     <a:lnL w="6350" cap="flat" cmpd="sng" algn="ctr">
                       <a:solidFill>
                         <a:srgbClr val="D8E2EA"/>
@@ -9480,7 +9039,7 @@
                     <a:bodyPr/>
                     <a:lstStyle/>
                     <a:p>
-                      <a:pPr algn="ctr" indent="0" marL="0">
+                      <a:pPr marL="0" indent="0" algn="ctr">
                         <a:buNone/>
                       </a:pPr>
                       <a:r>
@@ -9501,7 +9060,7 @@
                       </a:endParaRPr>
                     </a:p>
                   </a:txBody>
-                  <a:tcPr marL="91440" marR="91440" marT="45720" marB="45720" anchor="ctr">
+                  <a:tcPr anchor="ctr">
                     <a:lnL w="6350" cap="flat" cmpd="sng" algn="ctr">
                       <a:solidFill>
                         <a:srgbClr val="D8E2EA"/>
@@ -9548,7 +9107,7 @@
                     <a:bodyPr/>
                     <a:lstStyle/>
                     <a:p>
-                      <a:pPr algn="ctr" indent="0" marL="0">
+                      <a:pPr marL="0" indent="0" algn="ctr">
                         <a:buNone/>
                       </a:pPr>
                       <a:r>
@@ -9569,7 +9128,7 @@
                       </a:endParaRPr>
                     </a:p>
                   </a:txBody>
-                  <a:tcPr marL="91440" marR="91440" marT="45720" marB="45720" anchor="ctr">
+                  <a:tcPr anchor="ctr">
                     <a:lnL w="6350" cap="flat" cmpd="sng" algn="ctr">
                       <a:solidFill>
                         <a:srgbClr val="D8E2EA"/>
@@ -9611,6 +9170,11 @@
                     </a:solidFill>
                   </a:tcPr>
                 </a:tc>
+                <a:extLst>
+                  <a:ext uri="{0D108BD9-81ED-4DB2-BD59-A6C34878D82A}">
+                    <a16:rowId xmlns:a16="http://schemas.microsoft.com/office/drawing/2014/main" val="10004"/>
+                  </a:ext>
+                </a:extLst>
               </a:tr>
               <a:tr h="365760">
                 <a:tc>
@@ -9618,7 +9182,7 @@
                     <a:bodyPr/>
                     <a:lstStyle/>
                     <a:p>
-                      <a:pPr algn="l" indent="0" marL="0">
+                      <a:pPr marL="0" indent="0" algn="l">
                         <a:buNone/>
                       </a:pPr>
                       <a:r>
@@ -9639,7 +9203,7 @@
                       </a:endParaRPr>
                     </a:p>
                   </a:txBody>
-                  <a:tcPr marL="91440" marR="91440" marT="45720" marB="45720" anchor="ctr">
+                  <a:tcPr anchor="ctr">
                     <a:lnL w="6350" cap="flat" cmpd="sng" algn="ctr">
                       <a:solidFill>
                         <a:srgbClr val="D8E2EA"/>
@@ -9686,7 +9250,7 @@
                     <a:bodyPr/>
                     <a:lstStyle/>
                     <a:p>
-                      <a:pPr algn="ctr" indent="0" marL="0">
+                      <a:pPr marL="0" indent="0" algn="ctr">
                         <a:buNone/>
                       </a:pPr>
                       <a:r>
@@ -9707,7 +9271,7 @@
                       </a:endParaRPr>
                     </a:p>
                   </a:txBody>
-                  <a:tcPr marL="91440" marR="91440" marT="45720" marB="45720" anchor="ctr">
+                  <a:tcPr anchor="ctr">
                     <a:lnL w="6350" cap="flat" cmpd="sng" algn="ctr">
                       <a:solidFill>
                         <a:srgbClr val="D8E2EA"/>
@@ -9754,7 +9318,7 @@
                     <a:bodyPr/>
                     <a:lstStyle/>
                     <a:p>
-                      <a:pPr algn="ctr" indent="0" marL="0">
+                      <a:pPr marL="0" indent="0" algn="ctr">
                         <a:buNone/>
                       </a:pPr>
                       <a:r>
@@ -9775,7 +9339,7 @@
                       </a:endParaRPr>
                     </a:p>
                   </a:txBody>
-                  <a:tcPr marL="91440" marR="91440" marT="45720" marB="45720" anchor="ctr">
+                  <a:tcPr anchor="ctr">
                     <a:lnL w="6350" cap="flat" cmpd="sng" algn="ctr">
                       <a:solidFill>
                         <a:srgbClr val="D8E2EA"/>
@@ -9822,7 +9386,7 @@
                     <a:bodyPr/>
                     <a:lstStyle/>
                     <a:p>
-                      <a:pPr algn="ctr" indent="0" marL="0">
+                      <a:pPr marL="0" indent="0" algn="ctr">
                         <a:buNone/>
                       </a:pPr>
                       <a:r>
@@ -9843,7 +9407,7 @@
                       </a:endParaRPr>
                     </a:p>
                   </a:txBody>
-                  <a:tcPr marL="91440" marR="91440" marT="45720" marB="45720" anchor="ctr">
+                  <a:tcPr anchor="ctr">
                     <a:lnL w="6350" cap="flat" cmpd="sng" algn="ctr">
                       <a:solidFill>
                         <a:srgbClr val="D8E2EA"/>
@@ -9890,7 +9454,7 @@
                     <a:bodyPr/>
                     <a:lstStyle/>
                     <a:p>
-                      <a:pPr algn="ctr" indent="0" marL="0">
+                      <a:pPr marL="0" indent="0" algn="ctr">
                         <a:buNone/>
                       </a:pPr>
                       <a:r>
@@ -9911,7 +9475,7 @@
                       </a:endParaRPr>
                     </a:p>
                   </a:txBody>
-                  <a:tcPr marL="91440" marR="91440" marT="45720" marB="45720" anchor="ctr">
+                  <a:tcPr anchor="ctr">
                     <a:lnL w="6350" cap="flat" cmpd="sng" algn="ctr">
                       <a:solidFill>
                         <a:srgbClr val="D8E2EA"/>
@@ -9958,7 +9522,7 @@
                     <a:bodyPr/>
                     <a:lstStyle/>
                     <a:p>
-                      <a:pPr algn="ctr" indent="0" marL="0">
+                      <a:pPr marL="0" indent="0" algn="ctr">
                         <a:buNone/>
                       </a:pPr>
                       <a:r>
@@ -9979,7 +9543,7 @@
                       </a:endParaRPr>
                     </a:p>
                   </a:txBody>
-                  <a:tcPr marL="91440" marR="91440" marT="45720" marB="45720" anchor="ctr">
+                  <a:tcPr anchor="ctr">
                     <a:lnL w="6350" cap="flat" cmpd="sng" algn="ctr">
                       <a:solidFill>
                         <a:srgbClr val="D8E2EA"/>
@@ -10026,7 +9590,7 @@
                     <a:bodyPr/>
                     <a:lstStyle/>
                     <a:p>
-                      <a:pPr algn="ctr" indent="0" marL="0">
+                      <a:pPr marL="0" indent="0" algn="ctr">
                         <a:buNone/>
                       </a:pPr>
                       <a:r>
@@ -10047,7 +9611,7 @@
                       </a:endParaRPr>
                     </a:p>
                   </a:txBody>
-                  <a:tcPr marL="91440" marR="91440" marT="45720" marB="45720" anchor="ctr">
+                  <a:tcPr anchor="ctr">
                     <a:lnL w="6350" cap="flat" cmpd="sng" algn="ctr">
                       <a:solidFill>
                         <a:srgbClr val="D8E2EA"/>
@@ -10089,6 +9653,11 @@
                     </a:solidFill>
                   </a:tcPr>
                 </a:tc>
+                <a:extLst>
+                  <a:ext uri="{0D108BD9-81ED-4DB2-BD59-A6C34878D82A}">
+                    <a16:rowId xmlns:a16="http://schemas.microsoft.com/office/drawing/2014/main" val="10005"/>
+                  </a:ext>
+                </a:extLst>
               </a:tr>
               <a:tr h="365760">
                 <a:tc>
@@ -10096,7 +9665,7 @@
                     <a:bodyPr/>
                     <a:lstStyle/>
                     <a:p>
-                      <a:pPr algn="l" indent="0" marL="0">
+                      <a:pPr marL="0" indent="0" algn="l">
                         <a:buNone/>
                       </a:pPr>
                       <a:r>
@@ -10117,7 +9686,7 @@
                       </a:endParaRPr>
                     </a:p>
                   </a:txBody>
-                  <a:tcPr marL="91440" marR="91440" marT="45720" marB="45720" anchor="ctr">
+                  <a:tcPr anchor="ctr">
                     <a:lnL w="6350" cap="flat" cmpd="sng" algn="ctr">
                       <a:solidFill>
                         <a:srgbClr val="D8E2EA"/>
@@ -10164,7 +9733,7 @@
                     <a:bodyPr/>
                     <a:lstStyle/>
                     <a:p>
-                      <a:pPr algn="ctr" indent="0" marL="0">
+                      <a:pPr marL="0" indent="0" algn="ctr">
                         <a:buNone/>
                       </a:pPr>
                       <a:r>
@@ -10185,7 +9754,7 @@
                       </a:endParaRPr>
                     </a:p>
                   </a:txBody>
-                  <a:tcPr marL="91440" marR="91440" marT="45720" marB="45720" anchor="ctr">
+                  <a:tcPr anchor="ctr">
                     <a:lnL w="6350" cap="flat" cmpd="sng" algn="ctr">
                       <a:solidFill>
                         <a:srgbClr val="D8E2EA"/>
@@ -10232,7 +9801,7 @@
                     <a:bodyPr/>
                     <a:lstStyle/>
                     <a:p>
-                      <a:pPr algn="ctr" indent="0" marL="0">
+                      <a:pPr marL="0" indent="0" algn="ctr">
                         <a:buNone/>
                       </a:pPr>
                       <a:r>
@@ -10253,7 +9822,7 @@
                       </a:endParaRPr>
                     </a:p>
                   </a:txBody>
-                  <a:tcPr marL="91440" marR="91440" marT="45720" marB="45720" anchor="ctr">
+                  <a:tcPr anchor="ctr">
                     <a:lnL w="6350" cap="flat" cmpd="sng" algn="ctr">
                       <a:solidFill>
                         <a:srgbClr val="D8E2EA"/>
@@ -10300,7 +9869,7 @@
                     <a:bodyPr/>
                     <a:lstStyle/>
                     <a:p>
-                      <a:pPr algn="ctr" indent="0" marL="0">
+                      <a:pPr marL="0" indent="0" algn="ctr">
                         <a:buNone/>
                       </a:pPr>
                       <a:r>
@@ -10321,7 +9890,7 @@
                       </a:endParaRPr>
                     </a:p>
                   </a:txBody>
-                  <a:tcPr marL="91440" marR="91440" marT="45720" marB="45720" anchor="ctr">
+                  <a:tcPr anchor="ctr">
                     <a:lnL w="6350" cap="flat" cmpd="sng" algn="ctr">
                       <a:solidFill>
                         <a:srgbClr val="D8E2EA"/>
@@ -10368,7 +9937,7 @@
                     <a:bodyPr/>
                     <a:lstStyle/>
                     <a:p>
-                      <a:pPr algn="ctr" indent="0" marL="0">
+                      <a:pPr marL="0" indent="0" algn="ctr">
                         <a:buNone/>
                       </a:pPr>
                       <a:r>
@@ -10389,7 +9958,7 @@
                       </a:endParaRPr>
                     </a:p>
                   </a:txBody>
-                  <a:tcPr marL="91440" marR="91440" marT="45720" marB="45720" anchor="ctr">
+                  <a:tcPr anchor="ctr">
                     <a:lnL w="6350" cap="flat" cmpd="sng" algn="ctr">
                       <a:solidFill>
                         <a:srgbClr val="D8E2EA"/>
@@ -10436,7 +10005,7 @@
                     <a:bodyPr/>
                     <a:lstStyle/>
                     <a:p>
-                      <a:pPr algn="ctr" indent="0" marL="0">
+                      <a:pPr marL="0" indent="0" algn="ctr">
                         <a:buNone/>
                       </a:pPr>
                       <a:r>
@@ -10457,7 +10026,7 @@
                       </a:endParaRPr>
                     </a:p>
                   </a:txBody>
-                  <a:tcPr marL="91440" marR="91440" marT="45720" marB="45720" anchor="ctr">
+                  <a:tcPr anchor="ctr">
                     <a:lnL w="6350" cap="flat" cmpd="sng" algn="ctr">
                       <a:solidFill>
                         <a:srgbClr val="D8E2EA"/>
@@ -10504,7 +10073,7 @@
                     <a:bodyPr/>
                     <a:lstStyle/>
                     <a:p>
-                      <a:pPr algn="ctr" indent="0" marL="0">
+                      <a:pPr marL="0" indent="0" algn="ctr">
                         <a:buNone/>
                       </a:pPr>
                       <a:r>
@@ -10525,7 +10094,7 @@
                       </a:endParaRPr>
                     </a:p>
                   </a:txBody>
-                  <a:tcPr marL="91440" marR="91440" marT="45720" marB="45720" anchor="ctr">
+                  <a:tcPr anchor="ctr">
                     <a:lnL w="6350" cap="flat" cmpd="sng" algn="ctr">
                       <a:solidFill>
                         <a:srgbClr val="D8E2EA"/>
@@ -10567,6 +10136,11 @@
                     </a:solidFill>
                   </a:tcPr>
                 </a:tc>
+                <a:extLst>
+                  <a:ext uri="{0D108BD9-81ED-4DB2-BD59-A6C34878D82A}">
+                    <a16:rowId xmlns:a16="http://schemas.microsoft.com/office/drawing/2014/main" val="10006"/>
+                  </a:ext>
+                </a:extLst>
               </a:tr>
               <a:tr h="365760">
                 <a:tc>
@@ -10574,7 +10148,7 @@
                     <a:bodyPr/>
                     <a:lstStyle/>
                     <a:p>
-                      <a:pPr algn="l" indent="0" marL="0">
+                      <a:pPr marL="0" indent="0" algn="l">
                         <a:buNone/>
                       </a:pPr>
                       <a:r>
@@ -10595,7 +10169,7 @@
                       </a:endParaRPr>
                     </a:p>
                   </a:txBody>
-                  <a:tcPr marL="91440" marR="91440" marT="45720" marB="45720" anchor="ctr">
+                  <a:tcPr anchor="ctr">
                     <a:lnL w="6350" cap="flat" cmpd="sng" algn="ctr">
                       <a:solidFill>
                         <a:srgbClr val="D8E2EA"/>
@@ -10642,7 +10216,7 @@
                     <a:bodyPr/>
                     <a:lstStyle/>
                     <a:p>
-                      <a:pPr algn="ctr" indent="0" marL="0">
+                      <a:pPr marL="0" indent="0" algn="ctr">
                         <a:buNone/>
                       </a:pPr>
                       <a:r>
@@ -10663,7 +10237,7 @@
                       </a:endParaRPr>
                     </a:p>
                   </a:txBody>
-                  <a:tcPr marL="91440" marR="91440" marT="45720" marB="45720" anchor="ctr">
+                  <a:tcPr anchor="ctr">
                     <a:lnL w="6350" cap="flat" cmpd="sng" algn="ctr">
                       <a:solidFill>
                         <a:srgbClr val="D8E2EA"/>
@@ -10710,7 +10284,7 @@
                     <a:bodyPr/>
                     <a:lstStyle/>
                     <a:p>
-                      <a:pPr algn="ctr" indent="0" marL="0">
+                      <a:pPr marL="0" indent="0" algn="ctr">
                         <a:buNone/>
                       </a:pPr>
                       <a:r>
@@ -10731,7 +10305,7 @@
                       </a:endParaRPr>
                     </a:p>
                   </a:txBody>
-                  <a:tcPr marL="91440" marR="91440" marT="45720" marB="45720" anchor="ctr">
+                  <a:tcPr anchor="ctr">
                     <a:lnL w="6350" cap="flat" cmpd="sng" algn="ctr">
                       <a:solidFill>
                         <a:srgbClr val="D8E2EA"/>
@@ -10778,7 +10352,7 @@
                     <a:bodyPr/>
                     <a:lstStyle/>
                     <a:p>
-                      <a:pPr algn="ctr" indent="0" marL="0">
+                      <a:pPr marL="0" indent="0" algn="ctr">
                         <a:buNone/>
                       </a:pPr>
                       <a:r>
@@ -10799,7 +10373,7 @@
                       </a:endParaRPr>
                     </a:p>
                   </a:txBody>
-                  <a:tcPr marL="91440" marR="91440" marT="45720" marB="45720" anchor="ctr">
+                  <a:tcPr anchor="ctr">
                     <a:lnL w="6350" cap="flat" cmpd="sng" algn="ctr">
                       <a:solidFill>
                         <a:srgbClr val="D8E2EA"/>
@@ -10846,7 +10420,7 @@
                     <a:bodyPr/>
                     <a:lstStyle/>
                     <a:p>
-                      <a:pPr algn="ctr" indent="0" marL="0">
+                      <a:pPr marL="0" indent="0" algn="ctr">
                         <a:buNone/>
                       </a:pPr>
                       <a:r>
@@ -10867,7 +10441,7 @@
                       </a:endParaRPr>
                     </a:p>
                   </a:txBody>
-                  <a:tcPr marL="91440" marR="91440" marT="45720" marB="45720" anchor="ctr">
+                  <a:tcPr anchor="ctr">
                     <a:lnL w="6350" cap="flat" cmpd="sng" algn="ctr">
                       <a:solidFill>
                         <a:srgbClr val="D8E2EA"/>
@@ -10914,7 +10488,7 @@
                     <a:bodyPr/>
                     <a:lstStyle/>
                     <a:p>
-                      <a:pPr algn="ctr" indent="0" marL="0">
+                      <a:pPr marL="0" indent="0" algn="ctr">
                         <a:buNone/>
                       </a:pPr>
                       <a:r>
@@ -10935,7 +10509,7 @@
                       </a:endParaRPr>
                     </a:p>
                   </a:txBody>
-                  <a:tcPr marL="91440" marR="91440" marT="45720" marB="45720" anchor="ctr">
+                  <a:tcPr anchor="ctr">
                     <a:lnL w="6350" cap="flat" cmpd="sng" algn="ctr">
                       <a:solidFill>
                         <a:srgbClr val="D8E2EA"/>
@@ -10982,7 +10556,7 @@
                     <a:bodyPr/>
                     <a:lstStyle/>
                     <a:p>
-                      <a:pPr algn="ctr" indent="0" marL="0">
+                      <a:pPr marL="0" indent="0" algn="ctr">
                         <a:buNone/>
                       </a:pPr>
                       <a:r>
@@ -11003,7 +10577,7 @@
                       </a:endParaRPr>
                     </a:p>
                   </a:txBody>
-                  <a:tcPr marL="91440" marR="91440" marT="45720" marB="45720" anchor="ctr">
+                  <a:tcPr anchor="ctr">
                     <a:lnL w="6350" cap="flat" cmpd="sng" algn="ctr">
                       <a:solidFill>
                         <a:srgbClr val="D8E2EA"/>
@@ -11045,6 +10619,11 @@
                     </a:solidFill>
                   </a:tcPr>
                 </a:tc>
+                <a:extLst>
+                  <a:ext uri="{0D108BD9-81ED-4DB2-BD59-A6C34878D82A}">
+                    <a16:rowId xmlns:a16="http://schemas.microsoft.com/office/drawing/2014/main" val="10007"/>
+                  </a:ext>
+                </a:extLst>
               </a:tr>
             </a:tbl>
           </a:graphicData>
@@ -11052,7 +10631,7 @@
       </p:graphicFrame>
       <p:sp>
         <p:nvSpPr>
-          <p:cNvPr id="5" name="Shape 2"/>
+          <p:cNvPr id="4" name="Shape 2"/>
           <p:cNvSpPr/>
           <p:nvPr/>
         </p:nvSpPr>
@@ -11076,6 +10655,13 @@
             <a:prstDash val="solid"/>
           </a:ln>
         </p:spPr>
+        <p:txBody>
+          <a:bodyPr/>
+          <a:lstStyle/>
+          <a:p>
+            <a:endParaRPr/>
+          </a:p>
+        </p:txBody>
       </p:sp>
       <p:sp>
         <p:nvSpPr>
@@ -11098,7 +10684,7 @@
           <a:bodyPr wrap="square" lIns="0" tIns="0" rIns="0" bIns="0" rtlCol="0" anchor="ctr"/>
           <a:lstStyle/>
           <a:p>
-            <a:pPr indent="0" marL="0">
+            <a:pPr marL="0" indent="0">
               <a:buNone/>
             </a:pPr>
             <a:r>
@@ -11112,9 +10698,6 @@
               </a:rPr>
               <a:t>Leitura:  </a:t>
             </a:r>
-            <a:pPr indent="0" marL="0">
-              <a:buNone/>
-            </a:pPr>
             <a:r>
               <a:rPr lang="en-US" sz="1150" dirty="0">
                 <a:solidFill>
@@ -11146,6 +10729,7 @@
         <a:solidFill>
           <a:srgbClr val="FFFFFF"/>
         </a:solidFill>
+        <a:effectLst/>
       </p:bgPr>
     </p:bg>
     <p:spTree>
@@ -11183,11 +10767,11 @@
           <a:bodyPr wrap="square" lIns="0" tIns="0" rIns="0" bIns="0" rtlCol="0" anchor="ctr"/>
           <a:lstStyle/>
           <a:p>
-            <a:pPr indent="0" marL="0">
+            <a:pPr marL="0" indent="0">
               <a:buNone/>
             </a:pPr>
             <a:r>
-              <a:rPr lang="en-US" sz="1100" b="1" spc="200" kern="0" dirty="0">
+              <a:rPr lang="en-US" sz="1100" b="1" kern="0" spc="200" dirty="0">
                 <a:solidFill>
                   <a:srgbClr val="1C7293"/>
                 </a:solidFill>
@@ -11222,7 +10806,7 @@
           <a:bodyPr wrap="square" lIns="0" tIns="0" rIns="0" bIns="0" rtlCol="0" anchor="ctr"/>
           <a:lstStyle/>
           <a:p>
-            <a:pPr indent="0" marL="0">
+            <a:pPr marL="0" indent="0">
               <a:buNone/>
             </a:pPr>
             <a:r>
@@ -11242,14 +10826,14 @@
       </p:sp>
       <p:pic>
         <p:nvPicPr>
-          <p:cNvPr id="4" name="Image 0" descr="D:/Iniciação Cientifica/Projeto_IVS_Censo22/banco_de_dados/eda/figuras/histogramas.png">    </p:cNvPr>
+          <p:cNvPr id="4" name="Image 0" descr="D:/Iniciação Cientifica/Projeto_IVS_Censo22/banco_de_dados/eda/figuras/histogramas.png"/>
           <p:cNvPicPr>
             <a:picLocks noChangeAspect="1"/>
           </p:cNvPicPr>
           <p:nvPr/>
         </p:nvPicPr>
         <p:blipFill>
-          <a:blip r:embed="rId1"/>
+          <a:blip r:embed="rId3"/>
           <a:stretch>
             <a:fillRect/>
           </a:stretch>
@@ -11422,6 +11006,7 @@
         <a:solidFill>
           <a:srgbClr val="FFFFFF"/>
         </a:solidFill>
+        <a:effectLst/>
       </p:bgPr>
     </p:bg>
     <p:spTree>
@@ -11459,11 +11044,11 @@
           <a:bodyPr wrap="square" lIns="0" tIns="0" rIns="0" bIns="0" rtlCol="0" anchor="ctr"/>
           <a:lstStyle/>
           <a:p>
-            <a:pPr indent="0" marL="0">
+            <a:pPr marL="0" indent="0">
               <a:buNone/>
             </a:pPr>
             <a:r>
-              <a:rPr lang="en-US" sz="1100" b="1" spc="200" kern="0" dirty="0">
+              <a:rPr lang="en-US" sz="1100" b="1" kern="0" spc="200" dirty="0">
                 <a:solidFill>
                   <a:srgbClr val="1C7293"/>
                 </a:solidFill>
@@ -11498,7 +11083,7 @@
           <a:bodyPr wrap="square" lIns="0" tIns="0" rIns="0" bIns="0" rtlCol="0" anchor="ctr"/>
           <a:lstStyle/>
           <a:p>
-            <a:pPr indent="0" marL="0">
+            <a:pPr marL="0" indent="0">
               <a:buNone/>
             </a:pPr>
             <a:r>
@@ -11518,14 +11103,14 @@
       </p:sp>
       <p:pic>
         <p:nvPicPr>
-          <p:cNvPr id="4" name="Image 0" descr="D:/Iniciação Cientifica/Projeto_IVS_Censo22/banco_de_dados/eda/figuras/boxplots_por_regiao.png">    </p:cNvPr>
+          <p:cNvPr id="4" name="Image 0" descr="D:/Iniciação Cientifica/Projeto_IVS_Censo22/banco_de_dados/eda/figuras/boxplots_por_regiao.png"/>
           <p:cNvPicPr>
             <a:picLocks noChangeAspect="1"/>
           </p:cNvPicPr>
           <p:nvPr/>
         </p:nvPicPr>
         <p:blipFill>
-          <a:blip r:embed="rId1"/>
+          <a:blip r:embed="rId3"/>
           <a:stretch>
             <a:fillRect/>
           </a:stretch>
@@ -11604,7 +11189,7 @@
                 <a:ea typeface="Calibri" pitchFamily="34" charset="-122"/>
                 <a:cs typeface="Calibri" pitchFamily="34" charset="-120"/>
               </a:rPr>
-              <a:t>Nordeste lidera esgoto e lixo inadequados e o menor rendimento.</a:t>
+              <a:t>Nordeste lidera o lixo inadequado e tem a menor renda (mediana R$ 1.693).</a:t>
             </a:r>
             <a:endParaRPr lang="en-US" sz="1300" dirty="0"/>
           </a:p>
@@ -11674,6 +11259,7 @@
         <a:solidFill>
           <a:srgbClr val="FFFFFF"/>
         </a:solidFill>
+        <a:effectLst/>
       </p:bgPr>
     </p:bg>
     <p:spTree>
@@ -11711,11 +11297,11 @@
           <a:bodyPr wrap="square" lIns="0" tIns="0" rIns="0" bIns="0" rtlCol="0" anchor="ctr"/>
           <a:lstStyle/>
           <a:p>
-            <a:pPr indent="0" marL="0">
+            <a:pPr marL="0" indent="0">
               <a:buNone/>
             </a:pPr>
             <a:r>
-              <a:rPr lang="en-US" sz="1100" b="1" spc="200" kern="0" dirty="0">
+              <a:rPr lang="en-US" sz="1100" b="1" kern="0" spc="200" dirty="0">
                 <a:solidFill>
                   <a:srgbClr val="1C7293"/>
                 </a:solidFill>
@@ -11750,7 +11336,7 @@
           <a:bodyPr wrap="square" lIns="0" tIns="0" rIns="0" bIns="0" rtlCol="0" anchor="ctr"/>
           <a:lstStyle/>
           <a:p>
-            <a:pPr indent="0" marL="0">
+            <a:pPr marL="0" indent="0">
               <a:buNone/>
             </a:pPr>
             <a:r>
@@ -11770,7 +11356,7 @@
       </p:sp>
       <p:graphicFrame>
         <p:nvGraphicFramePr>
-          <p:cNvPr id="4" name="Chart 0" descr=""/>
+          <p:cNvPr id="4" name="Chart 0"/>
           <p:cNvGraphicFramePr/>
           <p:nvPr/>
         </p:nvGraphicFramePr>
@@ -11778,9 +11364,9 @@
           <a:off x="365760" y="1280160"/>
           <a:ext cx="5394960" cy="3566160"/>
         </p:xfrm>
-        <a:graphic xmlns:a="http://schemas.openxmlformats.org/drawingml/2006/main">
+        <a:graphic>
           <a:graphicData uri="http://schemas.openxmlformats.org/drawingml/2006/chart">
-            <c:chart xmlns:c="http://schemas.openxmlformats.org/drawingml/2006/chart" r:id="rId1"/>
+            <c:chart xmlns:c="http://schemas.openxmlformats.org/drawingml/2006/chart" xmlns:r="http://schemas.openxmlformats.org/officeDocument/2006/relationships" r:id="rId3"/>
           </a:graphicData>
         </a:graphic>
       </p:graphicFrame>
@@ -11918,6 +11504,7 @@
         <a:solidFill>
           <a:srgbClr val="FFFFFF"/>
         </a:solidFill>
+        <a:effectLst/>
       </p:bgPr>
     </p:bg>
     <p:spTree>
@@ -11955,11 +11542,11 @@
           <a:bodyPr wrap="square" lIns="0" tIns="0" rIns="0" bIns="0" rtlCol="0" anchor="ctr"/>
           <a:lstStyle/>
           <a:p>
-            <a:pPr indent="0" marL="0">
+            <a:pPr marL="0" indent="0">
               <a:buNone/>
             </a:pPr>
             <a:r>
-              <a:rPr lang="en-US" sz="1100" b="1" spc="200" kern="0" dirty="0">
+              <a:rPr lang="en-US" sz="1100" b="1" kern="0" spc="200" dirty="0">
                 <a:solidFill>
                   <a:srgbClr val="1C7293"/>
                 </a:solidFill>
@@ -11994,7 +11581,7 @@
           <a:bodyPr wrap="square" lIns="0" tIns="0" rIns="0" bIns="0" rtlCol="0" anchor="ctr"/>
           <a:lstStyle/>
           <a:p>
-            <a:pPr indent="0" marL="0">
+            <a:pPr marL="0" indent="0">
               <a:buNone/>
             </a:pPr>
             <a:r>
@@ -12014,14 +11601,14 @@
       </p:sp>
       <p:pic>
         <p:nvPicPr>
-          <p:cNvPr id="4" name="Image 0" descr="D:/Iniciação Cientifica/Projeto_IVS_Censo22/banco_de_dados/eda/figuras/matriz_correlacao.png">    </p:cNvPr>
+          <p:cNvPr id="4" name="Image 0" descr="D:/Iniciação Cientifica/Projeto_IVS_Censo22/banco_de_dados/eda/figuras/matriz_correlacao.png"/>
           <p:cNvPicPr>
             <a:picLocks noChangeAspect="1"/>
           </p:cNvPicPr>
           <p:nvPr/>
         </p:nvPicPr>
         <p:blipFill>
-          <a:blip r:embed="rId1"/>
+          <a:blip r:embed="rId3"/>
           <a:stretch>
             <a:fillRect/>
           </a:stretch>
@@ -12062,6 +11649,13 @@
             <a:prstDash val="solid"/>
           </a:ln>
         </p:spPr>
+        <p:txBody>
+          <a:bodyPr/>
+          <a:lstStyle/>
+          <a:p>
+            <a:endParaRPr/>
+          </a:p>
+        </p:txBody>
       </p:sp>
       <p:sp>
         <p:nvSpPr>
@@ -12084,7 +11678,7 @@
           <a:bodyPr wrap="square" lIns="0" tIns="0" rIns="0" bIns="0" rtlCol="0" anchor="ctr"/>
           <a:lstStyle/>
           <a:p>
-            <a:pPr indent="0" marL="0">
+            <a:pPr marL="0" indent="0">
               <a:buNone/>
             </a:pPr>
             <a:r>
@@ -12098,9 +11692,6 @@
               </a:rPr>
               <a:t>−0,81  </a:t>
             </a:r>
-            <a:pPr indent="0" marL="0">
-              <a:buNone/>
-            </a:pPr>
             <a:r>
               <a:rPr lang="en-US" sz="1050" dirty="0">
                 <a:solidFill>
@@ -12142,6 +11733,13 @@
             <a:prstDash val="solid"/>
           </a:ln>
         </p:spPr>
+        <p:txBody>
+          <a:bodyPr/>
+          <a:lstStyle/>
+          <a:p>
+            <a:endParaRPr/>
+          </a:p>
+        </p:txBody>
       </p:sp>
       <p:sp>
         <p:nvSpPr>
@@ -12164,7 +11762,7 @@
           <a:bodyPr wrap="square" lIns="0" tIns="0" rIns="0" bIns="0" rtlCol="0" anchor="ctr"/>
           <a:lstStyle/>
           <a:p>
-            <a:pPr indent="0" marL="0">
+            <a:pPr marL="0" indent="0">
               <a:buNone/>
             </a:pPr>
             <a:r>
@@ -12178,9 +11776,6 @@
               </a:rPr>
               <a:t>−0,75  </a:t>
             </a:r>
-            <a:pPr indent="0" marL="0">
-              <a:buNone/>
-            </a:pPr>
             <a:r>
               <a:rPr lang="en-US" sz="1050" dirty="0">
                 <a:solidFill>
@@ -12222,6 +11817,13 @@
             <a:prstDash val="solid"/>
           </a:ln>
         </p:spPr>
+        <p:txBody>
+          <a:bodyPr/>
+          <a:lstStyle/>
+          <a:p>
+            <a:endParaRPr/>
+          </a:p>
+        </p:txBody>
       </p:sp>
       <p:sp>
         <p:nvSpPr>
@@ -12244,7 +11846,7 @@
           <a:bodyPr wrap="square" lIns="0" tIns="0" rIns="0" bIns="0" rtlCol="0" anchor="ctr"/>
           <a:lstStyle/>
           <a:p>
-            <a:pPr indent="0" marL="0">
+            <a:pPr marL="0" indent="0">
               <a:buNone/>
             </a:pPr>
             <a:r>
@@ -12258,9 +11860,6 @@
               </a:rPr>
               <a:t>−0,04  </a:t>
             </a:r>
-            <a:pPr indent="0" marL="0">
-              <a:buNone/>
-            </a:pPr>
             <a:r>
               <a:rPr lang="en-US" sz="1050" dirty="0">
                 <a:solidFill>
@@ -12292,6 +11891,7 @@
         <a:solidFill>
           <a:srgbClr val="FFFFFF"/>
         </a:solidFill>
+        <a:effectLst/>
       </p:bgPr>
     </p:bg>
     <p:spTree>
@@ -12329,11 +11929,11 @@
           <a:bodyPr wrap="square" lIns="0" tIns="0" rIns="0" bIns="0" rtlCol="0" anchor="ctr"/>
           <a:lstStyle/>
           <a:p>
-            <a:pPr indent="0" marL="0">
+            <a:pPr marL="0" indent="0">
               <a:buNone/>
             </a:pPr>
             <a:r>
-              <a:rPr lang="en-US" sz="1100" b="1" spc="200" kern="0" dirty="0">
+              <a:rPr lang="en-US" sz="1100" b="1" kern="0" spc="200" dirty="0">
                 <a:solidFill>
                   <a:srgbClr val="1C7293"/>
                 </a:solidFill>
@@ -12368,7 +11968,7 @@
           <a:bodyPr wrap="square" lIns="0" tIns="0" rIns="0" bIns="0" rtlCol="0" anchor="ctr"/>
           <a:lstStyle/>
           <a:p>
-            <a:pPr indent="0" marL="0">
+            <a:pPr marL="0" indent="0">
               <a:buNone/>
             </a:pPr>
             <a:r>
@@ -12388,14 +11988,14 @@
       </p:sp>
       <p:pic>
         <p:nvPicPr>
-          <p:cNvPr id="4" name="Image 0" descr="D:/Iniciação Cientifica/Projeto_IVS_Censo22/banco_de_dados/eda/figuras/missing_por_municipio.png">    </p:cNvPr>
+          <p:cNvPr id="4" name="Image 0" descr="D:/Iniciação Cientifica/Projeto_IVS_Censo22/banco_de_dados/eda/figuras/missing_por_municipio.png"/>
           <p:cNvPicPr>
             <a:picLocks noChangeAspect="1"/>
           </p:cNvPicPr>
           <p:nvPr/>
         </p:nvPicPr>
         <p:blipFill>
-          <a:blip r:embed="rId1"/>
+          <a:blip r:embed="rId3"/>
           <a:stretch>
             <a:fillRect/>
           </a:stretch>
@@ -12829,4 +12429,319 @@
     </a:ext>
   </a:extLst>
 </a:theme>
+</file>
+
+<file path=ppt/theme/theme2.xml><?xml version="1.0" encoding="utf-8"?>
+<a:theme xmlns:a="http://schemas.openxmlformats.org/drawingml/2006/main" name="Tema do Office">
+  <a:themeElements>
+    <a:clrScheme name="Office">
+      <a:dk1>
+        <a:sysClr val="windowText" lastClr="000000"/>
+      </a:dk1>
+      <a:lt1>
+        <a:sysClr val="window" lastClr="FFFFFF"/>
+      </a:lt1>
+      <a:dk2>
+        <a:srgbClr val="0E2841"/>
+      </a:dk2>
+      <a:lt2>
+        <a:srgbClr val="E8E8E8"/>
+      </a:lt2>
+      <a:accent1>
+        <a:srgbClr val="156082"/>
+      </a:accent1>
+      <a:accent2>
+        <a:srgbClr val="E97132"/>
+      </a:accent2>
+      <a:accent3>
+        <a:srgbClr val="196B24"/>
+      </a:accent3>
+      <a:accent4>
+        <a:srgbClr val="0F9ED5"/>
+      </a:accent4>
+      <a:accent5>
+        <a:srgbClr val="A02B93"/>
+      </a:accent5>
+      <a:accent6>
+        <a:srgbClr val="4EA72E"/>
+      </a:accent6>
+      <a:hlink>
+        <a:srgbClr val="467886"/>
+      </a:hlink>
+      <a:folHlink>
+        <a:srgbClr val="96607D"/>
+      </a:folHlink>
+    </a:clrScheme>
+    <a:fontScheme name="Office">
+      <a:majorFont>
+        <a:latin typeface="Aptos Display" panose="02110004020202020204"/>
+        <a:ea typeface=""/>
+        <a:cs typeface=""/>
+        <a:font script="Jpan" typeface="游ゴシック Light"/>
+        <a:font script="Hang" typeface="맑은 고딕"/>
+        <a:font script="Hans" typeface="等线 Light"/>
+        <a:font script="Hant" typeface="新細明體"/>
+        <a:font script="Arab" typeface="Times New Roman"/>
+        <a:font script="Hebr" typeface="Times New Roman"/>
+        <a:font script="Thai" typeface="Angsana New"/>
+        <a:font script="Ethi" typeface="Nyala"/>
+        <a:font script="Beng" typeface="Vrinda"/>
+        <a:font script="Gujr" typeface="Shruti"/>
+        <a:font script="Khmr" typeface="MoolBoran"/>
+        <a:font script="Knda" typeface="Tunga"/>
+        <a:font script="Guru" typeface="Raavi"/>
+        <a:font script="Cans" typeface="Euphemia"/>
+        <a:font script="Cher" typeface="Plantagenet Cherokee"/>
+        <a:font script="Yiii" typeface="Microsoft Yi Baiti"/>
+        <a:font script="Tibt" typeface="Microsoft Himalaya"/>
+        <a:font script="Thaa" typeface="MV Boli"/>
+        <a:font script="Deva" typeface="Mangal"/>
+        <a:font script="Telu" typeface="Gautami"/>
+        <a:font script="Taml" typeface="Latha"/>
+        <a:font script="Syrc" typeface="Estrangelo Edessa"/>
+        <a:font script="Orya" typeface="Kalinga"/>
+        <a:font script="Mlym" typeface="Kartika"/>
+        <a:font script="Laoo" typeface="DokChampa"/>
+        <a:font script="Sinh" typeface="Iskoola Pota"/>
+        <a:font script="Mong" typeface="Mongolian Baiti"/>
+        <a:font script="Viet" typeface="Times New Roman"/>
+        <a:font script="Uigh" typeface="Microsoft Uighur"/>
+        <a:font script="Geor" typeface="Sylfaen"/>
+        <a:font script="Armn" typeface="Arial"/>
+        <a:font script="Bugi" typeface="Leelawadee UI"/>
+        <a:font script="Bopo" typeface="Microsoft JhengHei"/>
+        <a:font script="Java" typeface="Javanese Text"/>
+        <a:font script="Lisu" typeface="Segoe UI"/>
+        <a:font script="Mymr" typeface="Myanmar Text"/>
+        <a:font script="Nkoo" typeface="Ebrima"/>
+        <a:font script="Olck" typeface="Nirmala UI"/>
+        <a:font script="Osma" typeface="Ebrima"/>
+        <a:font script="Phag" typeface="Phagspa"/>
+        <a:font script="Syrn" typeface="Estrangelo Edessa"/>
+        <a:font script="Syrj" typeface="Estrangelo Edessa"/>
+        <a:font script="Syre" typeface="Estrangelo Edessa"/>
+        <a:font script="Sora" typeface="Nirmala UI"/>
+        <a:font script="Tale" typeface="Microsoft Tai Le"/>
+        <a:font script="Talu" typeface="Microsoft New Tai Lue"/>
+        <a:font script="Tfng" typeface="Ebrima"/>
+      </a:majorFont>
+      <a:minorFont>
+        <a:latin typeface="Aptos" panose="02110004020202020204"/>
+        <a:ea typeface=""/>
+        <a:cs typeface=""/>
+        <a:font script="Jpan" typeface="游ゴシック"/>
+        <a:font script="Hang" typeface="맑은 고딕"/>
+        <a:font script="Hans" typeface="等线"/>
+        <a:font script="Hant" typeface="新細明體"/>
+        <a:font script="Arab" typeface="Arial"/>
+        <a:font script="Hebr" typeface="Arial"/>
+        <a:font script="Thai" typeface="Cordia New"/>
+        <a:font script="Ethi" typeface="Nyala"/>
+        <a:font script="Beng" typeface="Vrinda"/>
+        <a:font script="Gujr" typeface="Shruti"/>
+        <a:font script="Khmr" typeface="DaunPenh"/>
+        <a:font script="Knda" typeface="Tunga"/>
+        <a:font script="Guru" typeface="Raavi"/>
+        <a:font script="Cans" typeface="Euphemia"/>
+        <a:font script="Cher" typeface="Plantagenet Cherokee"/>
+        <a:font script="Yiii" typeface="Microsoft Yi Baiti"/>
+        <a:font script="Tibt" typeface="Microsoft Himalaya"/>
+        <a:font script="Thaa" typeface="MV Boli"/>
+        <a:font script="Deva" typeface="Mangal"/>
+        <a:font script="Telu" typeface="Gautami"/>
+        <a:font script="Taml" typeface="Latha"/>
+        <a:font script="Syrc" typeface="Estrangelo Edessa"/>
+        <a:font script="Orya" typeface="Kalinga"/>
+        <a:font script="Mlym" typeface="Kartika"/>
+        <a:font script="Laoo" typeface="DokChampa"/>
+        <a:font script="Sinh" typeface="Iskoola Pota"/>
+        <a:font script="Mong" typeface="Mongolian Baiti"/>
+        <a:font script="Viet" typeface="Arial"/>
+        <a:font script="Uigh" typeface="Microsoft Uighur"/>
+        <a:font script="Geor" typeface="Sylfaen"/>
+        <a:font script="Armn" typeface="Arial"/>
+        <a:font script="Bugi" typeface="Leelawadee UI"/>
+        <a:font script="Bopo" typeface="Microsoft JhengHei"/>
+        <a:font script="Java" typeface="Javanese Text"/>
+        <a:font script="Lisu" typeface="Segoe UI"/>
+        <a:font script="Mymr" typeface="Myanmar Text"/>
+        <a:font script="Nkoo" typeface="Ebrima"/>
+        <a:font script="Olck" typeface="Nirmala UI"/>
+        <a:font script="Osma" typeface="Ebrima"/>
+        <a:font script="Phag" typeface="Phagspa"/>
+        <a:font script="Syrn" typeface="Estrangelo Edessa"/>
+        <a:font script="Syrj" typeface="Estrangelo Edessa"/>
+        <a:font script="Syre" typeface="Estrangelo Edessa"/>
+        <a:font script="Sora" typeface="Nirmala UI"/>
+        <a:font script="Tale" typeface="Microsoft Tai Le"/>
+        <a:font script="Talu" typeface="Microsoft New Tai Lue"/>
+        <a:font script="Tfng" typeface="Ebrima"/>
+      </a:minorFont>
+    </a:fontScheme>
+    <a:fmtScheme name="Office">
+      <a:fillStyleLst>
+        <a:solidFill>
+          <a:schemeClr val="phClr"/>
+        </a:solidFill>
+        <a:gradFill rotWithShape="1">
+          <a:gsLst>
+            <a:gs pos="0">
+              <a:schemeClr val="phClr">
+                <a:lumMod val="110000"/>
+                <a:satMod val="105000"/>
+                <a:tint val="67000"/>
+              </a:schemeClr>
+            </a:gs>
+            <a:gs pos="50000">
+              <a:schemeClr val="phClr">
+                <a:lumMod val="105000"/>
+                <a:satMod val="103000"/>
+                <a:tint val="73000"/>
+              </a:schemeClr>
+            </a:gs>
+            <a:gs pos="100000">
+              <a:schemeClr val="phClr">
+                <a:lumMod val="105000"/>
+                <a:satMod val="109000"/>
+                <a:tint val="81000"/>
+              </a:schemeClr>
+            </a:gs>
+          </a:gsLst>
+          <a:lin ang="5400000" scaled="0"/>
+        </a:gradFill>
+        <a:gradFill rotWithShape="1">
+          <a:gsLst>
+            <a:gs pos="0">
+              <a:schemeClr val="phClr">
+                <a:satMod val="103000"/>
+                <a:lumMod val="102000"/>
+                <a:tint val="94000"/>
+              </a:schemeClr>
+            </a:gs>
+            <a:gs pos="50000">
+              <a:schemeClr val="phClr">
+                <a:satMod val="110000"/>
+                <a:lumMod val="100000"/>
+                <a:shade val="100000"/>
+              </a:schemeClr>
+            </a:gs>
+            <a:gs pos="100000">
+              <a:schemeClr val="phClr">
+                <a:lumMod val="99000"/>
+                <a:satMod val="120000"/>
+                <a:shade val="78000"/>
+              </a:schemeClr>
+            </a:gs>
+          </a:gsLst>
+          <a:lin ang="5400000" scaled="0"/>
+        </a:gradFill>
+      </a:fillStyleLst>
+      <a:lnStyleLst>
+        <a:ln w="12700" cap="flat" cmpd="sng" algn="ctr">
+          <a:solidFill>
+            <a:schemeClr val="phClr"/>
+          </a:solidFill>
+          <a:prstDash val="solid"/>
+          <a:miter lim="800000"/>
+        </a:ln>
+        <a:ln w="19050" cap="flat" cmpd="sng" algn="ctr">
+          <a:solidFill>
+            <a:schemeClr val="phClr"/>
+          </a:solidFill>
+          <a:prstDash val="solid"/>
+          <a:miter lim="800000"/>
+        </a:ln>
+        <a:ln w="25400" cap="flat" cmpd="sng" algn="ctr">
+          <a:solidFill>
+            <a:schemeClr val="phClr"/>
+          </a:solidFill>
+          <a:prstDash val="solid"/>
+          <a:miter lim="800000"/>
+        </a:ln>
+      </a:lnStyleLst>
+      <a:effectStyleLst>
+        <a:effectStyle>
+          <a:effectLst/>
+        </a:effectStyle>
+        <a:effectStyle>
+          <a:effectLst/>
+        </a:effectStyle>
+        <a:effectStyle>
+          <a:effectLst>
+            <a:outerShdw blurRad="57150" dist="19050" dir="5400000" algn="ctr" rotWithShape="0">
+              <a:srgbClr val="000000">
+                <a:alpha val="63000"/>
+              </a:srgbClr>
+            </a:outerShdw>
+          </a:effectLst>
+        </a:effectStyle>
+      </a:effectStyleLst>
+      <a:bgFillStyleLst>
+        <a:solidFill>
+          <a:schemeClr val="phClr"/>
+        </a:solidFill>
+        <a:solidFill>
+          <a:schemeClr val="phClr">
+            <a:tint val="95000"/>
+            <a:satMod val="170000"/>
+          </a:schemeClr>
+        </a:solidFill>
+        <a:gradFill rotWithShape="1">
+          <a:gsLst>
+            <a:gs pos="0">
+              <a:schemeClr val="phClr">
+                <a:tint val="93000"/>
+                <a:satMod val="150000"/>
+                <a:shade val="98000"/>
+                <a:lumMod val="102000"/>
+              </a:schemeClr>
+            </a:gs>
+            <a:gs pos="50000">
+              <a:schemeClr val="phClr">
+                <a:tint val="98000"/>
+                <a:satMod val="130000"/>
+                <a:shade val="90000"/>
+                <a:lumMod val="103000"/>
+              </a:schemeClr>
+            </a:gs>
+            <a:gs pos="100000">
+              <a:schemeClr val="phClr">
+                <a:shade val="63000"/>
+                <a:satMod val="120000"/>
+              </a:schemeClr>
+            </a:gs>
+          </a:gsLst>
+          <a:lin ang="5400000" scaled="0"/>
+        </a:gradFill>
+      </a:bgFillStyleLst>
+    </a:fmtScheme>
+  </a:themeElements>
+  <a:objectDefaults>
+    <a:lnDef>
+      <a:spPr/>
+      <a:bodyPr/>
+      <a:lstStyle/>
+      <a:style>
+        <a:lnRef idx="2">
+          <a:schemeClr val="accent1"/>
+        </a:lnRef>
+        <a:fillRef idx="0">
+          <a:schemeClr val="accent1"/>
+        </a:fillRef>
+        <a:effectRef idx="1">
+          <a:schemeClr val="accent1"/>
+        </a:effectRef>
+        <a:fontRef idx="minor">
+          <a:schemeClr val="tx1"/>
+        </a:fontRef>
+      </a:style>
+    </a:lnDef>
+  </a:objectDefaults>
+  <a:extraClrSchemeLst/>
+  <a:extLst>
+    <a:ext uri="{05A4C25C-085E-4340-85A3-A5531E510DB2}">
+      <thm15:themeFamily xmlns:thm15="http://schemas.microsoft.com/office/thememl/2012/main" name="Office Theme" id="{2E142A2C-CD16-42D6-873A-C26D2A0506FA}" vid="{1BDDFF52-6CD6-40A5-AB3C-68EB2F1E4D0A}"/>
+    </a:ext>
+  </a:extLst>
+</a:theme>
 </file>
</xml_diff>